<commit_message>
docs: make technology slides visual and interactive
</commit_message>
<xml_diff>
--- a/docs/submission/ExaMate-Technologies-VI-20261026.pptx
+++ b/docs/submission/ExaMate-Technologies-VI-20261026.pptx
@@ -516,37 +516,37 @@
           <a:lstStyle/>
           <a:p>
             <a:r>
-              <a:t>Tài · mở đầu 25 giây</a:t>
-            </a:r>
-          </a:p>
-          <a:p>
-            <a:r>
-              <a:t>“Bộ slide này giải thích vì sao nhóm chọn công nghệ và công nghệ đó</a:t>
-            </a:r>
-          </a:p>
-          <a:p>
-            <a:r>
-              <a:t>            giải quyết phần nào của ExaMate. Nhóm dùng model có sẵn, không tự</a:t>
-            </a:r>
-          </a:p>
-          <a:p>
-            <a:r>
-              <a:t>            train. Hai năng lực AI chính là RAG có nguồn và structured output</a:t>
-            </a:r>
-          </a:p>
-          <a:p>
-            <a:r>
-              <a:t>            được đưa vào luồng luyện tập.” Đây là bản bổ sung kỹ thuật, không</a:t>
-            </a:r>
-          </a:p>
-          <a:p>
-            <a:r>
-              <a:t>            thay slide demo ngắn. Không đọc cả 15 slide nếu thời gian bảo vệ chỉ</a:t>
-            </a:r>
-          </a:p>
-          <a:p>
-            <a:r>
-              <a:t>            8 phút.</a:t>
+              <a:t>Lời thuyết trình và điểm chỉ code</a:t>
+            </a:r>
+          </a:p>
+          <a:p>
+            <a:r>
+              <a:t>Tài · mở đầu 25 giây “Bộ slide này giải thích vì sao nhóm chọn công</a:t>
+            </a:r>
+          </a:p>
+          <a:p>
+            <a:r>
+              <a:t>            nghệ và công nghệ đó giải quyết phần nào của ExaMate. Nhóm dùng</a:t>
+            </a:r>
+          </a:p>
+          <a:p>
+            <a:r>
+              <a:t>            model có sẵn, không tự train. Hai năng lực AI chính là RAG có nguồn</a:t>
+            </a:r>
+          </a:p>
+          <a:p>
+            <a:r>
+              <a:t>            và structured output được đưa vào luồng luyện tập.” Đây là bản bổ</a:t>
+            </a:r>
+          </a:p>
+          <a:p>
+            <a:r>
+              <a:t>            sung kỹ thuật, không thay slide demo ngắn. Không đọc cả 15 slide nếu</a:t>
+            </a:r>
+          </a:p>
+          <a:p>
+            <a:r>
+              <a:t>            thời gian bảo vệ chỉ 8 phút.</a:t>
             </a:r>
           </a:p>
           <a:p/>
@@ -622,42 +622,47 @@
           <a:lstStyle/>
           <a:p>
             <a:r>
-              <a:t>Tài · 50 giây</a:t>
-            </a:r>
-          </a:p>
-          <a:p>
-            <a:r>
-              <a:t>“Generation không tự lưu bộ quiz/thẻ. Confirm riêng mới tạo snapshot</a:t>
-            </a:r>
-          </a:p>
-          <a:p>
-            <a:r>
-              <a:t>            cá nhân. Khi nộp bài, server đọc answer key chứ không nhận score</a:t>
-            </a:r>
-          </a:p>
-          <a:p>
-            <a:r>
-              <a:t>            client. Flashcards lưu remembered/needs_review, không chứng minh đã</a:t>
-            </a:r>
-          </a:p>
-          <a:p>
-            <a:r>
-              <a:t>            thành thạo. Nếu mất ACK sau commit thì retry cùng key/payload, không</a:t>
-            </a:r>
-          </a:p>
-          <a:p>
-            <a:r>
-              <a:t>            tạo lượt mới để thoát lỗi; confirm unknown cần GET trước.” Bộ đã lưu</a:t>
-            </a:r>
-          </a:p>
-          <a:p>
-            <a:r>
-              <a:t>            mặc định 90 ngày, nguồn xóa báo unavailable, manager không đọc của</a:t>
-            </a:r>
-          </a:p>
-          <a:p>
-            <a:r>
-              <a:t>            người khác. Code: StudyCoachPanel.tsx, StudyFlashcardsPanel.tsx,</a:t>
+              <a:t>Lời thuyết trình và điểm chỉ code</a:t>
+            </a:r>
+          </a:p>
+          <a:p>
+            <a:r>
+              <a:t>Tài · 50 giây “Generation không tự lưu bộ quiz/thẻ. Confirm riêng</a:t>
+            </a:r>
+          </a:p>
+          <a:p>
+            <a:r>
+              <a:t>            mới tạo snapshot cá nhân. Khi nộp bài, server đọc answer key chứ</a:t>
+            </a:r>
+          </a:p>
+          <a:p>
+            <a:r>
+              <a:t>            không nhận score client. Flashcards lưu remembered/needs_review,</a:t>
+            </a:r>
+          </a:p>
+          <a:p>
+            <a:r>
+              <a:t>            không chứng minh đã thành thạo. Nếu mất ACK sau commit thì retry</a:t>
+            </a:r>
+          </a:p>
+          <a:p>
+            <a:r>
+              <a:t>            cùng key/payload, không tạo lượt mới để thoát lỗi; confirm unknown</a:t>
+            </a:r>
+          </a:p>
+          <a:p>
+            <a:r>
+              <a:t>            cần GET trước.” Bộ đã lưu mặc định 90 ngày, nguồn xóa báo</a:t>
+            </a:r>
+          </a:p>
+          <a:p>
+            <a:r>
+              <a:t>            unavailable, manager không đọc của người khác. Code:</a:t>
+            </a:r>
+          </a:p>
+          <a:p>
+            <a:r>
+              <a:t>            StudyCoachPanel.tsx, StudyFlashcardsPanel.tsx,</a:t>
             </a:r>
           </a:p>
           <a:p>
@@ -738,42 +743,47 @@
           <a:lstStyle/>
           <a:p>
             <a:r>
-              <a:t>Thắng · SSE 35 giây; Tài · history 15 giây</a:t>
-            </a:r>
-          </a:p>
-          <a:p>
-            <a:r>
-              <a:t>“SSE không bắt buộc EventSource. Nhóm cần POST body và CSRF headers</a:t>
-            </a:r>
-          </a:p>
-          <a:p>
-            <a:r>
-              <a:t>            nên dùng fetch/ReadableStream. Một network chunk không bằng một</a:t>
-            </a:r>
-          </a:p>
-          <a:p>
-            <a:r>
-              <a:t>            event; parser phải giữ buffer. General được phát delta, RAG giữ nội</a:t>
-            </a:r>
-          </a:p>
-          <a:p>
-            <a:r>
-              <a:t>            dung tới khi validator xong, không bỏ SSE toàn ứng dụng.” Tài bổ</a:t>
-            </a:r>
-          </a:p>
-          <a:p>
-            <a:r>
-              <a:t>            sung: receipt xác minh snapshot, không chứng minh answer đúng;</a:t>
-            </a:r>
-          </a:p>
-          <a:p>
-            <a:r>
-              <a:t>            history mở lại và follow-up không trộn source cũ thành evidence mới.</a:t>
-            </a:r>
-          </a:p>
-          <a:p>
-            <a:r>
-              <a:t>            Epoch/revision ngăn stream A cập nhật B.</a:t>
+              <a:t>Lời thuyết trình và điểm chỉ code</a:t>
+            </a:r>
+          </a:p>
+          <a:p>
+            <a:r>
+              <a:t>Thắng · SSE 35 giây; Tài · history 15 giây “SSE không bắt buộc</a:t>
+            </a:r>
+          </a:p>
+          <a:p>
+            <a:r>
+              <a:t>            EventSource. Nhóm cần POST body và CSRF headers nên dùng</a:t>
+            </a:r>
+          </a:p>
+          <a:p>
+            <a:r>
+              <a:t>            fetch/ReadableStream. Một network chunk không bằng một event; parser</a:t>
+            </a:r>
+          </a:p>
+          <a:p>
+            <a:r>
+              <a:t>            phải giữ buffer. General được phát delta, RAG giữ nội dung tới khi</a:t>
+            </a:r>
+          </a:p>
+          <a:p>
+            <a:r>
+              <a:t>            validator xong, không bỏ SSE toàn ứng dụng.” Tài bổ sung: receipt</a:t>
+            </a:r>
+          </a:p>
+          <a:p>
+            <a:r>
+              <a:t>            xác minh snapshot, không chứng minh answer đúng; history mở lại và</a:t>
+            </a:r>
+          </a:p>
+          <a:p>
+            <a:r>
+              <a:t>            follow-up không trộn source cũ thành evidence mới. Epoch/revision</a:t>
+            </a:r>
+          </a:p>
+          <a:p>
+            <a:r>
+              <a:t>            ngăn stream A cập nhật B.</a:t>
             </a:r>
           </a:p>
           <a:p/>
@@ -849,47 +859,47 @@
           <a:lstStyle/>
           <a:p>
             <a:r>
-              <a:t>Thắng · 50 giây</a:t>
-            </a:r>
-          </a:p>
-          <a:p>
-            <a:r>
-              <a:t>“Whisper pretrained chạy trên API host, không trong browser và không</a:t>
-            </a:r>
-          </a:p>
-          <a:p>
-            <a:r>
-              <a:t>            do nhóm train. ONNX là định dạng/runtime; q8 giảm tài nguyên nhưng</a:t>
-            </a:r>
-          </a:p>
-          <a:p>
-            <a:r>
-              <a:t>            có trade-off. Audio dài trong trần 60 giây dùng chunk 30/stride 5 để</a:t>
-            </a:r>
-          </a:p>
-          <a:p>
-            <a:r>
-              <a:t>            không chỉ đọc cửa sổ đầu. Timeout phải terminate worker/subprocess</a:t>
-            </a:r>
-          </a:p>
-          <a:p>
-            <a:r>
-              <a:t>            và cleanup, không chỉ Promise.race.” Không gọi toàn app offline:</a:t>
-            </a:r>
-          </a:p>
-          <a:p>
-            <a:r>
-              <a:t>            Supabase/Gemini vẫn cần mạng. Code: audio-inspector.ts,</a:t>
-            </a:r>
-          </a:p>
-          <a:p>
-            <a:r>
-              <a:t>            local-inference-options.ts, local-speech-runtime.ts,</a:t>
-            </a:r>
-          </a:p>
-          <a:p>
-            <a:r>
-              <a:t>            use-speech-input.ts.</a:t>
+              <a:t>Lời thuyết trình và điểm chỉ code</a:t>
+            </a:r>
+          </a:p>
+          <a:p>
+            <a:r>
+              <a:t>Thắng · 50 giây “Whisper pretrained chạy trên API host, không trong</a:t>
+            </a:r>
+          </a:p>
+          <a:p>
+            <a:r>
+              <a:t>            browser và không do nhóm train. ONNX là định dạng/runtime; q8 giảm</a:t>
+            </a:r>
+          </a:p>
+          <a:p>
+            <a:r>
+              <a:t>            tài nguyên nhưng có trade-off. Audio dài trong trần 60 giây dùng</a:t>
+            </a:r>
+          </a:p>
+          <a:p>
+            <a:r>
+              <a:t>            chunk 30/stride 5 để không chỉ đọc cửa sổ đầu. Timeout phải</a:t>
+            </a:r>
+          </a:p>
+          <a:p>
+            <a:r>
+              <a:t>            terminate worker/subprocess và cleanup, không chỉ Promise.race.”</a:t>
+            </a:r>
+          </a:p>
+          <a:p>
+            <a:r>
+              <a:t>            Không gọi toàn app offline: Supabase/Gemini vẫn cần mạng. Code:</a:t>
+            </a:r>
+          </a:p>
+          <a:p>
+            <a:r>
+              <a:t>            audio-inspector.ts, local-inference-options.ts,</a:t>
+            </a:r>
+          </a:p>
+          <a:p>
+            <a:r>
+              <a:t>            local-speech-runtime.ts, use-speech-input.ts.</a:t>
             </a:r>
           </a:p>
           <a:p/>
@@ -965,52 +975,52 @@
           <a:lstStyle/>
           <a:p>
             <a:r>
-              <a:t>Tài · 45 giây</a:t>
-            </a:r>
-          </a:p>
-          <a:p>
-            <a:r>
-              <a:t>“Telemetry ghi sau không ngăn chi phí đã xảy ra, nên admission</a:t>
-            </a:r>
-          </a:p>
-          <a:p>
-            <a:r>
-              <a:t>            reserve trước provider. Một RAG request có thể có embedding và</a:t>
-            </a:r>
-          </a:p>
-          <a:p>
-            <a:r>
-              <a:t>            generation; chỉ đếm HTTP request là thiếu. Token null không coi là</a:t>
-            </a:r>
-          </a:p>
-          <a:p>
-            <a:r>
-              <a:t>            zero, cộng decimal/BIGINT không dùng Number tùy tiện. Dashboard chỉ</a:t>
-            </a:r>
-          </a:p>
-          <a:p>
-            <a:r>
-              <a:t>            manager và membership được kiểm mới trong transaction.” Refresh dùng</a:t>
-            </a:r>
-          </a:p>
-          <a:p>
-            <a:r>
-              <a:t>            generation chung cho overview/cost/detail; chuyển page operation</a:t>
-            </a:r>
-          </a:p>
-          <a:p>
-            <a:r>
-              <a:t>            không ép đọc cost nếu cohort giữ nguyên. Code:</a:t>
-            </a:r>
-          </a:p>
-          <a:p>
-            <a:r>
-              <a:t>            ai-admission.service.ts, ai-usage.service.ts,</a:t>
-            </a:r>
-          </a:p>
-          <a:p>
-            <a:r>
-              <a:t>            ai-usage-dashboard.service.ts.</a:t>
+              <a:t>Lời thuyết trình và điểm chỉ code</a:t>
+            </a:r>
+          </a:p>
+          <a:p>
+            <a:r>
+              <a:t>Tài · 45 giây “Telemetry ghi sau không ngăn chi phí đã xảy ra, nên</a:t>
+            </a:r>
+          </a:p>
+          <a:p>
+            <a:r>
+              <a:t>            admission reserve trước provider. Một RAG request có thể có</a:t>
+            </a:r>
+          </a:p>
+          <a:p>
+            <a:r>
+              <a:t>            embedding và generation; chỉ đếm HTTP request là thiếu. Token null</a:t>
+            </a:r>
+          </a:p>
+          <a:p>
+            <a:r>
+              <a:t>            không coi là zero, cộng decimal/BIGINT không dùng Number tùy tiện.</a:t>
+            </a:r>
+          </a:p>
+          <a:p>
+            <a:r>
+              <a:t>            Dashboard chỉ manager và membership được kiểm mới trong</a:t>
+            </a:r>
+          </a:p>
+          <a:p>
+            <a:r>
+              <a:t>            transaction.” Refresh dùng generation chung cho</a:t>
+            </a:r>
+          </a:p>
+          <a:p>
+            <a:r>
+              <a:t>            overview/cost/detail; chuyển page operation không ép đọc cost nếu</a:t>
+            </a:r>
+          </a:p>
+          <a:p>
+            <a:r>
+              <a:t>            cohort giữ nguyên. Code: ai-admission.service.ts,</a:t>
+            </a:r>
+          </a:p>
+          <a:p>
+            <a:r>
+              <a:t>            ai-usage.service.ts, ai-usage-dashboard.service.ts.</a:t>
             </a:r>
           </a:p>
           <a:p/>
@@ -1086,42 +1096,47 @@
           <a:lstStyle/>
           <a:p>
             <a:r>
-              <a:t>Tài · 40 giây</a:t>
-            </a:r>
-          </a:p>
-          <a:p>
-            <a:r>
-              <a:t>“Container chỉ đóng gói ứng dụng, không tự làm Auth/Storage/Gemini</a:t>
-            </a:r>
-          </a:p>
-          <a:p>
-            <a:r>
-              <a:t>            offline. Dữ liệu bền do DB/Storage, không vì state React hay image</a:t>
-            </a:r>
-          </a:p>
-          <a:p>
-            <a:r>
-              <a:t>            Docker. nginx giữ proxy/Origin và không buffer SSE; TLS CA phải được</a:t>
-            </a:r>
-          </a:p>
-          <a:p>
-            <a:r>
-              <a:t>            giữ, không tắt kiểm chứng để kết nối.” Không trình chiếu .env, không</a:t>
-            </a:r>
-          </a:p>
-          <a:p>
-            <a:r>
-              <a:t>            chạy lại migration/cloud write khi chỉ khởi động demo. Đây là mô tả</a:t>
-            </a:r>
-          </a:p>
-          <a:p>
-            <a:r>
-              <a:t>            deployment đã lưu, không một đợt triển khai mới. Code: compose.yaml,</a:t>
-            </a:r>
-          </a:p>
-          <a:p>
-            <a:r>
-              <a:t>            compose.ca.yaml, Dockerfiles và infra/nginx/default.conf.</a:t>
+              <a:t>Lời thuyết trình và điểm chỉ code</a:t>
+            </a:r>
+          </a:p>
+          <a:p>
+            <a:r>
+              <a:t>Tài · 40 giây “Container chỉ đóng gói ứng dụng, không tự làm</a:t>
+            </a:r>
+          </a:p>
+          <a:p>
+            <a:r>
+              <a:t>            Auth/Storage/Gemini offline. Dữ liệu bền do DB/Storage, không vì</a:t>
+            </a:r>
+          </a:p>
+          <a:p>
+            <a:r>
+              <a:t>            state React hay image Docker. nginx giữ proxy/Origin và không buffer</a:t>
+            </a:r>
+          </a:p>
+          <a:p>
+            <a:r>
+              <a:t>            SSE; TLS CA phải được giữ, không tắt kiểm chứng để kết nối.” Không</a:t>
+            </a:r>
+          </a:p>
+          <a:p>
+            <a:r>
+              <a:t>            trình chiếu .env, không chạy lại migration/cloud write khi chỉ khởi</a:t>
+            </a:r>
+          </a:p>
+          <a:p>
+            <a:r>
+              <a:t>            động demo. Đây là mô tả deployment đã lưu, không một đợt triển khai</a:t>
+            </a:r>
+          </a:p>
+          <a:p>
+            <a:r>
+              <a:t>            mới. Code: compose.yaml, compose.ca.yaml, Dockerfiles và</a:t>
+            </a:r>
+          </a:p>
+          <a:p>
+            <a:r>
+              <a:t>            infra/nginx/default.conf.</a:t>
             </a:r>
           </a:p>
           <a:p/>
@@ -1197,52 +1212,52 @@
           <a:lstStyle/>
           <a:p>
             <a:r>
-              <a:t>Cả hai · kết 40 giây</a:t>
-            </a:r>
-          </a:p>
-          <a:p>
-            <a:r>
-              <a:t>“Không lớp test nào tự chứng minh mọi câu AI đúng. Fixture provider</a:t>
-            </a:r>
-          </a:p>
-          <a:p>
-            <a:r>
-              <a:t>            kiểm đường runtime, không chất lượng model; citation tồn tại chưa</a:t>
-            </a:r>
-          </a:p>
-          <a:p>
-            <a:r>
-              <a:t>            chứng minh claim grounding. Baseline strict 75% khác</a:t>
-            </a:r>
-          </a:p>
-          <a:p>
-            <a:r>
-              <a:t>            semantic-content 90%; không dùng 1/1 của lượt cải tiến để nhận 100%.</a:t>
-            </a:r>
-          </a:p>
-          <a:p>
-            <a:r>
-              <a:t>            Human review Study Coach, micro/máy Thắng và các matrix pending vẫn</a:t>
-            </a:r>
-          </a:p>
-          <a:p>
-            <a:r>
-              <a:t>            theo bằng chứng.” Tài và Thắng nhận phần thực sự làm/hiểu; AI_USAGE</a:t>
-            </a:r>
-          </a:p>
-          <a:p>
-            <a:r>
-              <a:t>            công khai hỗ trợ và lỗi. Không nhận capability B có ≥3 LLM-called</a:t>
-            </a:r>
-          </a:p>
-          <a:p>
-            <a:r>
-              <a:t>            tools, không thêm TTS. Hướng capability là A RAG + C structured</a:t>
-            </a:r>
-          </a:p>
-          <a:p>
-            <a:r>
-              <a:t>            output, không tuyên bố RUBRIC_PASSED thay giảng viên.</a:t>
+              <a:t>Lời thuyết trình và điểm chỉ code</a:t>
+            </a:r>
+          </a:p>
+          <a:p>
+            <a:r>
+              <a:t>Cả hai · kết 40 giây “Không lớp test nào tự chứng minh mọi câu AI</a:t>
+            </a:r>
+          </a:p>
+          <a:p>
+            <a:r>
+              <a:t>            đúng. Fixture provider kiểm đường runtime, không chất lượng model;</a:t>
+            </a:r>
+          </a:p>
+          <a:p>
+            <a:r>
+              <a:t>            citation tồn tại chưa chứng minh claim grounding. Baseline strict</a:t>
+            </a:r>
+          </a:p>
+          <a:p>
+            <a:r>
+              <a:t>            75% khác semantic-content 90%; không dùng 1/1 của lượt cải tiến để</a:t>
+            </a:r>
+          </a:p>
+          <a:p>
+            <a:r>
+              <a:t>            nhận 100%. Human review Study Coach, micro/máy Thắng và các matrix</a:t>
+            </a:r>
+          </a:p>
+          <a:p>
+            <a:r>
+              <a:t>            pending vẫn theo bằng chứng.” Tài và Thắng nhận phần thực sự</a:t>
+            </a:r>
+          </a:p>
+          <a:p>
+            <a:r>
+              <a:t>            làm/hiểu; AI_USAGE công khai hỗ trợ và lỗi. Không nhận capability B</a:t>
+            </a:r>
+          </a:p>
+          <a:p>
+            <a:r>
+              <a:t>            có ≥3 LLM-called tools, không thêm TTS. Hướng capability là A RAG +</a:t>
+            </a:r>
+          </a:p>
+          <a:p>
+            <a:r>
+              <a:t>            C structured output, không tuyên bố RUBRIC_PASSED thay giảng viên.</a:t>
             </a:r>
           </a:p>
           <a:p/>
@@ -1318,42 +1333,42 @@
           <a:lstStyle/>
           <a:p>
             <a:r>
-              <a:t>Thắng · 40 giây, Tài bổ sung quyền</a:t>
-            </a:r>
-          </a:p>
-          <a:p>
-            <a:r>
-              <a:t>“React không gọi SQL hay cầm server key. Nest gom nghiệp vụ và xác</a:t>
-            </a:r>
-          </a:p>
-          <a:p>
-            <a:r>
-              <a:t>            minh principal; PostgreSQL lưu cả dữ liệu học tập lẫn vector.</a:t>
-            </a:r>
-          </a:p>
-          <a:p>
-            <a:r>
-              <a:t>            Supabase Auth và Storage là hai dịch vụ khác nhau. Gemini cần mạng,</a:t>
-            </a:r>
-          </a:p>
-          <a:p>
-            <a:r>
-              <a:t>            còn Whisper chạy trên API host. Nhóm không giữ DB transaction trong</a:t>
-            </a:r>
-          </a:p>
-          <a:p>
-            <a:r>
-              <a:t>            lúc chờ Gemini/Storage.” Sơ đồ là khái niệm theo source, không phải</a:t>
-            </a:r>
-          </a:p>
-          <a:p>
-            <a:r>
-              <a:t>            trace network mới. Code: App.tsx, app.module.ts,</a:t>
-            </a:r>
-          </a:p>
-          <a:p>
-            <a:r>
-              <a:t>            database.service.ts, compose.yaml.</a:t>
+              <a:t>Lời thuyết trình và điểm chỉ code</a:t>
+            </a:r>
+          </a:p>
+          <a:p>
+            <a:r>
+              <a:t>Thắng · 40 giây, Tài bổ sung quyền “React không gọi SQL hay cầm</a:t>
+            </a:r>
+          </a:p>
+          <a:p>
+            <a:r>
+              <a:t>            server key. Nest gom nghiệp vụ và xác minh principal; PostgreSQL lưu</a:t>
+            </a:r>
+          </a:p>
+          <a:p>
+            <a:r>
+              <a:t>            cả dữ liệu học tập lẫn vector. Supabase Auth và Storage là hai dịch</a:t>
+            </a:r>
+          </a:p>
+          <a:p>
+            <a:r>
+              <a:t>            vụ khác nhau. Gemini cần mạng, còn Whisper chạy trên API host. Nhóm</a:t>
+            </a:r>
+          </a:p>
+          <a:p>
+            <a:r>
+              <a:t>            không giữ DB transaction trong lúc chờ Gemini/Storage.” Sơ đồ là</a:t>
+            </a:r>
+          </a:p>
+          <a:p>
+            <a:r>
+              <a:t>            khái niệm theo source, không phải trace network mới. Code: App.tsx,</a:t>
+            </a:r>
+          </a:p>
+          <a:p>
+            <a:r>
+              <a:t>            app.module.ts, database.service.ts, compose.yaml.</a:t>
             </a:r>
           </a:p>
           <a:p/>
@@ -1429,52 +1444,52 @@
           <a:lstStyle/>
           <a:p>
             <a:r>
-              <a:t>Tài · 45 giây</a:t>
-            </a:r>
-          </a:p>
-          <a:p>
-            <a:r>
-              <a:t>“React giúp chia các màn thành component, còn hook quản lý request</a:t>
-            </a:r>
-          </a:p>
-          <a:p>
-            <a:r>
-              <a:t>            và state. Khi đổi từ khóa ở trang hai, request mới phải về trang một</a:t>
-            </a:r>
-          </a:p>
-          <a:p>
-            <a:r>
-              <a:t>            ngay; abort chỉ dừng tài nguyên, key/epoch mới quyết định response</a:t>
-            </a:r>
-          </a:p>
-          <a:p>
-            <a:r>
-              <a:t>            được apply. Giao diện dùng palette sẵn, Poppins/Heroicons, focus và</a:t>
-            </a:r>
-          </a:p>
-          <a:p>
-            <a:r>
-              <a:t>            control dễ thao tác.” Ví dụ kể lỗi query mới dùng page cũ hoặc</a:t>
-            </a:r>
-          </a:p>
-          <a:p>
-            <a:r>
-              <a:t>            response account cũ. Không nói dùng localStorage làm nguồn server,</a:t>
-            </a:r>
-          </a:p>
-          <a:p>
-            <a:r>
-              <a:t>            không coi ẩn nút là đủ phân quyền. Nếu hỏi sao không Next.js: chưa</a:t>
-            </a:r>
-          </a:p>
-          <a:p>
-            <a:r>
-              <a:t>            có nhu cầu SSR/SEO cho vùng workspace riêng tư; Vite đáp ứng</a:t>
-            </a:r>
-          </a:p>
-          <a:p>
-            <a:r>
-              <a:t>            dev/build hiện tại.</a:t>
+              <a:t>Lời thuyết trình và điểm chỉ code</a:t>
+            </a:r>
+          </a:p>
+          <a:p>
+            <a:r>
+              <a:t>Tài · 45 giây “React giúp chia các màn thành component, còn hook</a:t>
+            </a:r>
+          </a:p>
+          <a:p>
+            <a:r>
+              <a:t>            quản lý request và state. Khi đổi từ khóa ở trang hai, request mới</a:t>
+            </a:r>
+          </a:p>
+          <a:p>
+            <a:r>
+              <a:t>            phải về trang một ngay; abort chỉ dừng tài nguyên, key/epoch mới</a:t>
+            </a:r>
+          </a:p>
+          <a:p>
+            <a:r>
+              <a:t>            quyết định response được apply. Giao diện dùng palette sẵn,</a:t>
+            </a:r>
+          </a:p>
+          <a:p>
+            <a:r>
+              <a:t>            Poppins/Heroicons, focus và control dễ thao tác.” Ví dụ kể lỗi query</a:t>
+            </a:r>
+          </a:p>
+          <a:p>
+            <a:r>
+              <a:t>            mới dùng page cũ hoặc response account cũ. Không nói dùng</a:t>
+            </a:r>
+          </a:p>
+          <a:p>
+            <a:r>
+              <a:t>            localStorage làm nguồn server, không coi ẩn nút là đủ phân quyền.</a:t>
+            </a:r>
+          </a:p>
+          <a:p>
+            <a:r>
+              <a:t>            Nếu hỏi sao không Next.js: chưa có nhu cầu SSR/SEO cho vùng</a:t>
+            </a:r>
+          </a:p>
+          <a:p>
+            <a:r>
+              <a:t>            workspace riêng tư; Vite đáp ứng dev/build hiện tại.</a:t>
             </a:r>
           </a:p>
           <a:p/>
@@ -1550,32 +1565,32 @@
           <a:lstStyle/>
           <a:p>
             <a:r>
-              <a:t>Thắng · 40 giây</a:t>
-            </a:r>
-          </a:p>
-          <a:p>
-            <a:r>
-              <a:t>“Thắng đóng góp nền backend/Supabase và Gemini ban đầu; Tài tích hợp</a:t>
-            </a:r>
-          </a:p>
-          <a:p>
-            <a:r>
-              <a:t>            tiếp Auth/RLS và nghiệp vụ. Nest giúp controller không chứa cả</a:t>
-            </a:r>
-          </a:p>
-          <a:p>
-            <a:r>
-              <a:t>            pipeline AI. DI cho phép test giả SDK/Auth upstream trong khi Nest,</a:t>
-            </a:r>
-          </a:p>
-          <a:p>
-            <a:r>
-              <a:t>            authorization, service và PostgreSQL vẫn thật.” Code:</a:t>
-            </a:r>
-          </a:p>
-          <a:p>
-            <a:r>
-              <a:t>            assistant.controller.ts, auth.guard.ts, common/http.ts,</a:t>
+              <a:t>Lời thuyết trình và điểm chỉ code</a:t>
+            </a:r>
+          </a:p>
+          <a:p>
+            <a:r>
+              <a:t>Thắng · 40 giây “Thắng đóng góp nền backend/Supabase và Gemini ban</a:t>
+            </a:r>
+          </a:p>
+          <a:p>
+            <a:r>
+              <a:t>            đầu; Tài tích hợp tiếp Auth/RLS và nghiệp vụ. Nest giúp controller</a:t>
+            </a:r>
+          </a:p>
+          <a:p>
+            <a:r>
+              <a:t>            không chứa cả pipeline AI. DI cho phép test giả SDK/Auth upstream</a:t>
+            </a:r>
+          </a:p>
+          <a:p>
+            <a:r>
+              <a:t>            trong khi Nest, authorization, service và PostgreSQL vẫn thật.”</a:t>
+            </a:r>
+          </a:p>
+          <a:p>
+            <a:r>
+              <a:t>            Code: assistant.controller.ts, auth.guard.ts, common/http.ts,</a:t>
             </a:r>
           </a:p>
           <a:p>
@@ -1666,37 +1681,37 @@
           <a:lstStyle/>
           <a:p>
             <a:r>
-              <a:t>Tài · 45 giây</a:t>
-            </a:r>
-          </a:p>
-          <a:p>
-            <a:r>
-              <a:t>“Authentication trả lời bạn là ai, authorization trả lời bạn được</a:t>
-            </a:r>
-          </a:p>
-          <a:p>
-            <a:r>
-              <a:t>            làm gì. Phiên opaque HttpOnly khác JWT: browser không tự giữ access</a:t>
-            </a:r>
-          </a:p>
-          <a:p>
-            <a:r>
-              <a:t>            token trong localStorage. Mỗi workspace request dùng principal</a:t>
-            </a:r>
-          </a:p>
-          <a:p>
-            <a:r>
-              <a:t>            server xác minh; viewer không ghi dù sửa DOM. Manager cũng không đọc</a:t>
-            </a:r>
-          </a:p>
-          <a:p>
-            <a:r>
-              <a:t>            hội thoại/quiz riêng của người khác.” Google callback về Supabase</a:t>
-            </a:r>
-          </a:p>
-          <a:p>
-            <a:r>
-              <a:t>            khác callback về app. Code: auth.service.ts, auth.guard.ts,</a:t>
+              <a:t>Lời thuyết trình và điểm chỉ code</a:t>
+            </a:r>
+          </a:p>
+          <a:p>
+            <a:r>
+              <a:t>Tài · 45 giây “Authentication trả lời bạn là ai, authorization trả</a:t>
+            </a:r>
+          </a:p>
+          <a:p>
+            <a:r>
+              <a:t>            lời bạn được làm gì. Phiên opaque HttpOnly khác JWT: browser không</a:t>
+            </a:r>
+          </a:p>
+          <a:p>
+            <a:r>
+              <a:t>            tự giữ access token trong localStorage. Mỗi workspace request dùng</a:t>
+            </a:r>
+          </a:p>
+          <a:p>
+            <a:r>
+              <a:t>            principal server xác minh; viewer không ghi dù sửa DOM. Manager cũng</a:t>
+            </a:r>
+          </a:p>
+          <a:p>
+            <a:r>
+              <a:t>            không đọc hội thoại/quiz riêng của người khác.” Google callback về</a:t>
+            </a:r>
+          </a:p>
+          <a:p>
+            <a:r>
+              <a:t>            Supabase khác callback về app. Code: auth.service.ts, auth.guard.ts,</a:t>
             </a:r>
           </a:p>
           <a:p>
@@ -1782,27 +1797,32 @@
           <a:lstStyle/>
           <a:p>
             <a:r>
-              <a:t>Tài · 45 giây; Thắng nắm nền database</a:t>
-            </a:r>
-          </a:p>
-          <a:p>
-            <a:r>
-              <a:t>“PostgreSQL đáp ứng dữ liệu quan hệ còn pgvector bổ sung kiểu vector</a:t>
-            </a:r>
-          </a:p>
-          <a:p>
-            <a:r>
-              <a:t>            và phép khoảng cách. RLS là lớp DB, WHERE là scope ứng dụng; dùng cả</a:t>
-            </a:r>
-          </a:p>
-          <a:p>
-            <a:r>
-              <a:t>            hai. Runtime owner/BYPASSRLS sẽ làm mất ý nghĩa bảo vệ nên nhóm tách</a:t>
-            </a:r>
-          </a:p>
-          <a:p>
-            <a:r>
-              <a:t>            LOGIN business/Auth. Context transaction-local tránh rò pool giữa</a:t>
+              <a:t>Lời thuyết trình và điểm chỉ code</a:t>
+            </a:r>
+          </a:p>
+          <a:p>
+            <a:r>
+              <a:t>Tài · 45 giây; Thắng nắm nền database “PostgreSQL đáp ứng dữ liệu</a:t>
+            </a:r>
+          </a:p>
+          <a:p>
+            <a:r>
+              <a:t>            quan hệ còn pgvector bổ sung kiểu vector và phép khoảng cách. RLS là</a:t>
+            </a:r>
+          </a:p>
+          <a:p>
+            <a:r>
+              <a:t>            lớp DB, WHERE là scope ứng dụng; dùng cả hai. Runtime</a:t>
+            </a:r>
+          </a:p>
+          <a:p>
+            <a:r>
+              <a:t>            owner/BYPASSRLS sẽ làm mất ý nghĩa bảo vệ nên nhóm tách LOGIN</a:t>
+            </a:r>
+          </a:p>
+          <a:p>
+            <a:r>
+              <a:t>            business/Auth. Context transaction-local tránh rò pool giữa</a:t>
             </a:r>
           </a:p>
           <a:p>
@@ -1898,52 +1918,52 @@
           <a:lstStyle/>
           <a:p>
             <a:r>
-              <a:t>Thắng + Tài · 45 giây</a:t>
-            </a:r>
-          </a:p>
-          <a:p>
-            <a:r>
-              <a:t>“Nhóm chia theo trang và giữ overlap để giảm mất ngữ cảnh ở ranh</a:t>
-            </a:r>
-          </a:p>
-          <a:p>
-            <a:r>
-              <a:t>            giới. Các số là ký tự, không phải token. Signed URL được tạo sau</a:t>
-            </a:r>
-          </a:p>
-          <a:p>
-            <a:r>
-              <a:t>            authorize, không do model cung cấp. OCR chỉ dành trang không trích</a:t>
-            </a:r>
-          </a:p>
-          <a:p>
-            <a:r>
-              <a:t>            được text hữu ích, không tự chạy lại mọi tài liệu.” Cấu hình local</a:t>
-            </a:r>
-          </a:p>
-          <a:p>
-            <a:r>
-              <a:t>            ngày 26/10 đã đổi riêng GEMINI_OCR_MODEL sang gemini-3.5-flash-lite</a:t>
-            </a:r>
-          </a:p>
-          <a:p>
-            <a:r>
-              <a:t>            nhưng OCR vẫn tắt; source fallback vẫn 2.5-flash. Đó không phải kết</a:t>
-            </a:r>
-          </a:p>
-          <a:p>
-            <a:r>
-              <a:t>            quả benchmark OCR hoặc thay model generation của evaluation. Code:</a:t>
-            </a:r>
-          </a:p>
-          <a:p>
-            <a:r>
-              <a:t>            document-ingestion.service.ts, document-chunker.ts,</a:t>
-            </a:r>
-          </a:p>
-          <a:p>
-            <a:r>
-              <a:t>            document-ocr.service.ts.</a:t>
+              <a:t>Lời thuyết trình và điểm chỉ code</a:t>
+            </a:r>
+          </a:p>
+          <a:p>
+            <a:r>
+              <a:t>Thắng + Tài · 45 giây “Nhóm chia theo trang và giữ overlap để giảm</a:t>
+            </a:r>
+          </a:p>
+          <a:p>
+            <a:r>
+              <a:t>            mất ngữ cảnh ở ranh giới. Các số là ký tự, không phải token. Signed</a:t>
+            </a:r>
+          </a:p>
+          <a:p>
+            <a:r>
+              <a:t>            URL được tạo sau authorize, không do model cung cấp. OCR chỉ dành</a:t>
+            </a:r>
+          </a:p>
+          <a:p>
+            <a:r>
+              <a:t>            trang không trích được text hữu ích, không tự chạy lại mọi tài</a:t>
+            </a:r>
+          </a:p>
+          <a:p>
+            <a:r>
+              <a:t>            liệu.” Cấu hình local ngày 26/10 đã đổi riêng GEMINI_OCR_MODEL sang</a:t>
+            </a:r>
+          </a:p>
+          <a:p>
+            <a:r>
+              <a:t>            gemini-3.5-flash-lite nhưng OCR vẫn tắt; source fallback vẫn</a:t>
+            </a:r>
+          </a:p>
+          <a:p>
+            <a:r>
+              <a:t>            2.5-flash. Đó không phải kết quả benchmark OCR hoặc thay model</a:t>
+            </a:r>
+          </a:p>
+          <a:p>
+            <a:r>
+              <a:t>            generation của evaluation. Code: document-ingestion.service.ts,</a:t>
+            </a:r>
+          </a:p>
+          <a:p>
+            <a:r>
+              <a:t>            document-chunker.ts, document-ocr.service.ts.</a:t>
             </a:r>
           </a:p>
           <a:p/>
@@ -2019,52 +2039,52 @@
           <a:lstStyle/>
           <a:p>
             <a:r>
-              <a:t>Tài + Thắng · 50 giây</a:t>
-            </a:r>
-          </a:p>
-          <a:p>
-            <a:r>
-              <a:t>“RAG không train hay fine-tune; lấy evidence đúng quyền rồi mới yêu</a:t>
-            </a:r>
-          </a:p>
-          <a:p>
-            <a:r>
-              <a:t>            cầu model trả lời. Embedding dùng để so liên quan, generation mới</a:t>
-            </a:r>
-          </a:p>
-          <a:p>
-            <a:r>
-              <a:t>            viết answer. Ngưỡng 0,55 là source default, không 55% accuracy;</a:t>
-            </a:r>
-          </a:p>
-          <a:p>
-            <a:r>
-              <a:t>            runtime có thể khác. Citation map ID về document/page trên server,</a:t>
-            </a:r>
-          </a:p>
-          <a:p>
-            <a:r>
-              <a:t>            nhưng claim grounding còn phải đối chiếu.” Thắng có đóng góp RAG đã</a:t>
-            </a:r>
-          </a:p>
-          <a:p>
-            <a:r>
-              <a:t>            được Tài xác nhận, không gán riêng toàn bộ cho một người. Code:</a:t>
-            </a:r>
-          </a:p>
-          <a:p>
-            <a:r>
-              <a:t>            rag-retrieval.service.ts, rag-context.ts, source-markers.ts,</a:t>
-            </a:r>
-          </a:p>
-          <a:p>
-            <a:r>
-              <a:t>            prompt-registry.ts. Hỏi ngoài PDF có thể tốn query embedding nhưng</a:t>
-            </a:r>
-          </a:p>
-          <a:p>
-            <a:r>
-              <a:t>            không answer generation.</a:t>
+              <a:t>Lời thuyết trình và điểm chỉ code</a:t>
+            </a:r>
+          </a:p>
+          <a:p>
+            <a:r>
+              <a:t>Tài + Thắng · 50 giây “RAG không train hay fine-tune; lấy evidence</a:t>
+            </a:r>
+          </a:p>
+          <a:p>
+            <a:r>
+              <a:t>            đúng quyền rồi mới yêu cầu model trả lời. Embedding dùng để so liên</a:t>
+            </a:r>
+          </a:p>
+          <a:p>
+            <a:r>
+              <a:t>            quan, generation mới viết answer. Ngưỡng 0,55 là source default,</a:t>
+            </a:r>
+          </a:p>
+          <a:p>
+            <a:r>
+              <a:t>            không 55% accuracy; runtime có thể khác. Citation map ID về</a:t>
+            </a:r>
+          </a:p>
+          <a:p>
+            <a:r>
+              <a:t>            document/page trên server, nhưng claim grounding còn phải đối</a:t>
+            </a:r>
+          </a:p>
+          <a:p>
+            <a:r>
+              <a:t>            chiếu.” Thắng có đóng góp RAG đã được Tài xác nhận, không gán riêng</a:t>
+            </a:r>
+          </a:p>
+          <a:p>
+            <a:r>
+              <a:t>            toàn bộ cho một người. Code: rag-retrieval.service.ts,</a:t>
+            </a:r>
+          </a:p>
+          <a:p>
+            <a:r>
+              <a:t>            rag-context.ts, source-markers.ts, prompt-registry.ts. Hỏi ngoài PDF</a:t>
+            </a:r>
+          </a:p>
+          <a:p>
+            <a:r>
+              <a:t>            có thể tốn query embedding nhưng không answer generation.</a:t>
             </a:r>
           </a:p>
           <a:p/>
@@ -2140,37 +2160,37 @@
           <a:lstStyle/>
           <a:p>
             <a:r>
-              <a:t>Tài · 45 giây</a:t>
-            </a:r>
-          </a:p>
-          <a:p>
-            <a:r>
-              <a:t>“Nhóm chọn Gemini qua wrapper đang có, hỗ trợ generation và</a:t>
-            </a:r>
-          </a:p>
-          <a:p>
-            <a:r>
-              <a:t>            structured output. Không nói model chắc tốt nhất khi chưa so sánh.</a:t>
-            </a:r>
-          </a:p>
-          <a:p>
-            <a:r>
-              <a:t>            responseJsonSchema giúp định dạng nhưng server vẫn validate lại,</a:t>
-            </a:r>
-          </a:p>
-          <a:p>
-            <a:r>
-              <a:t>            reject JSON lỗi/truncated, thừa field, trùng câu/thẻ hoặc source</a:t>
-            </a:r>
-          </a:p>
-          <a:p>
-            <a:r>
-              <a:t>            giả. Answer key đúng kiểu chưa đồng nghĩa đúng kiến thức.” Model</a:t>
-            </a:r>
-          </a:p>
-          <a:p>
-            <a:r>
-              <a:t>            generation do GEMINI_MODEL quyết định; baseline giữ</a:t>
+              <a:t>Lời thuyết trình và điểm chỉ code</a:t>
+            </a:r>
+          </a:p>
+          <a:p>
+            <a:r>
+              <a:t>Tài · 45 giây “Nhóm chọn Gemini qua wrapper đang có, hỗ trợ</a:t>
+            </a:r>
+          </a:p>
+          <a:p>
+            <a:r>
+              <a:t>            generation và structured output. Không nói model chắc tốt nhất khi</a:t>
+            </a:r>
+          </a:p>
+          <a:p>
+            <a:r>
+              <a:t>            chưa so sánh. responseJsonSchema giúp định dạng nhưng server vẫn</a:t>
+            </a:r>
+          </a:p>
+          <a:p>
+            <a:r>
+              <a:t>            validate lại, reject JSON lỗi/truncated, thừa field, trùng câu/thẻ</a:t>
+            </a:r>
+          </a:p>
+          <a:p>
+            <a:r>
+              <a:t>            hoặc source giả. Answer key đúng kiểu chưa đồng nghĩa đúng kiến</a:t>
+            </a:r>
+          </a:p>
+          <a:p>
+            <a:r>
+              <a:t>            thức.” Model generation do GEMINI_MODEL quyết định; baseline giữ</a:t>
             </a:r>
           </a:p>
           <a:p>
@@ -5199,7 +5219,7 @@
       <p:grpSpPr/>
       <p:pic>
         <p:nvPicPr>
-          <p:cNvPr id="2" name="Picture 1" descr="01. ExaMate Công nghệ phía sau trải nghiệm."/>
+          <p:cNvPr id="2" name="Picture 1" descr="01. ExaMate. Công nghệ kể bằng trải nghiệm."/>
           <p:cNvPicPr>
             <a:picLocks noChangeAspect="1"/>
           </p:cNvPicPr>
@@ -5226,6 +5246,9 @@
   <p:clrMapOvr>
     <a:masterClrMapping/>
   </p:clrMapOvr>
+  <p:transition spd="med">
+    <p:fade/>
+  </p:transition>
 </p:sld>
 </file>
 
@@ -5241,7 +5264,7 @@
       <p:grpSpPr/>
       <p:pic>
         <p:nvPicPr>
-          <p:cNvPr id="2" name="Picture 1" descr="10. Người dùng xác nhận, server giữ nhất quán."/>
+          <p:cNvPr id="2" name="Picture 1" descr="10. Học bằng hành động, không chỉ đọc JSON."/>
           <p:cNvPicPr>
             <a:picLocks noChangeAspect="1"/>
           </p:cNvPicPr>
@@ -5268,6 +5291,9 @@
   <p:clrMapOvr>
     <a:masterClrMapping/>
   </p:clrMapOvr>
+  <p:transition spd="med">
+    <p:fade/>
+  </p:transition>
 </p:sld>
 </file>
 
@@ -5283,7 +5309,7 @@
       <p:grpSpPr/>
       <p:pic>
         <p:nvPicPr>
-          <p:cNvPr id="2" name="Picture 1" descr="11. Phản hồi nhanh, kiểm soát trọn vòng đời."/>
+          <p:cNvPr id="2" name="Picture 1" descr="11. Chữ chạy dần, quyền kiểm vẫn nguyên."/>
           <p:cNvPicPr>
             <a:picLocks noChangeAspect="1"/>
           </p:cNvPicPr>
@@ -5310,6 +5336,9 @@
   <p:clrMapOvr>
     <a:masterClrMapping/>
   </p:clrMapOvr>
+  <p:transition spd="med">
+    <p:fade/>
+  </p:transition>
 </p:sld>
 </file>
 
@@ -5325,7 +5354,7 @@
       <p:grpSpPr/>
       <p:pic>
         <p:nvPicPr>
-          <p:cNvPr id="2" name="Picture 1" descr="12. Giọng nói thành bản nháp có thể sửa."/>
+          <p:cNvPr id="2" name="Picture 1" descr="12. Nói → sửa bản chép → tự gửi."/>
           <p:cNvPicPr>
             <a:picLocks noChangeAspect="1"/>
           </p:cNvPicPr>
@@ -5352,6 +5381,9 @@
   <p:clrMapOvr>
     <a:masterClrMapping/>
   </p:clrMapOvr>
+  <p:transition spd="med">
+    <p:fade/>
+  </p:transition>
 </p:sld>
 </file>
 
@@ -5367,7 +5399,7 @@
       <p:grpSpPr/>
       <p:pic>
         <p:nvPicPr>
-          <p:cNvPr id="2" name="Picture 1" descr="13. Giữ chỗ trước, đo đúng sau lời gọi."/>
+          <p:cNvPr id="2" name="Picture 1" descr="13. Chặn trước. Đo đúng sau."/>
           <p:cNvPicPr>
             <a:picLocks noChangeAspect="1"/>
           </p:cNvPicPr>
@@ -5394,6 +5426,9 @@
   <p:clrMapOvr>
     <a:masterClrMapping/>
   </p:clrMapOvr>
+  <p:transition spd="med">
+    <p:fade/>
+  </p:transition>
 </p:sld>
 </file>
 
@@ -5409,7 +5444,7 @@
       <p:grpSpPr/>
       <p:pic>
         <p:nvPicPr>
-          <p:cNvPr id="2" name="Picture 1" descr="14. Đóng gói runtime, giữ dữ liệu bền."/>
+          <p:cNvPr id="2" name="Picture 1" descr="14. Đóng gói app. Giữ dữ liệu bền."/>
           <p:cNvPicPr>
             <a:picLocks noChangeAspect="1"/>
           </p:cNvPicPr>
@@ -5436,6 +5471,9 @@
   <p:clrMapOvr>
     <a:masterClrMapping/>
   </p:clrMapOvr>
+  <p:transition spd="med">
+    <p:fade/>
+  </p:transition>
 </p:sld>
 </file>
 
@@ -5451,7 +5489,7 @@
       <p:grpSpPr/>
       <p:pic>
         <p:nvPicPr>
-          <p:cNvPr id="2" name="Picture 1" descr="15. Kiểm cấu trúc, kiểm luồng chạy, rồi đối chiếu chất lượng."/>
+          <p:cNvPr id="2" name="Picture 1" descr="15. Đúng đường chạy. Đúng mức bằng chứng."/>
           <p:cNvPicPr>
             <a:picLocks noChangeAspect="1"/>
           </p:cNvPicPr>
@@ -5478,6 +5516,9 @@
   <p:clrMapOvr>
     <a:masterClrMapping/>
   </p:clrMapOvr>
+  <p:transition spd="med">
+    <p:fade/>
+  </p:transition>
 </p:sld>
 </file>
 
@@ -5493,7 +5534,7 @@
       <p:grpSpPr/>
       <p:pic>
         <p:nvPicPr>
-          <p:cNvPr id="2" name="Picture 1" descr="02. Mỗi lớp có một trách nhiệm."/>
+          <p:cNvPr id="2" name="Picture 1" descr="02. Một request. Ba ranh giới."/>
           <p:cNvPicPr>
             <a:picLocks noChangeAspect="1"/>
           </p:cNvPicPr>
@@ -5520,6 +5561,9 @@
   <p:clrMapOvr>
     <a:masterClrMapping/>
   </p:clrMapOvr>
+  <p:transition spd="med">
+    <p:fade/>
+  </p:transition>
 </p:sld>
 </file>
 
@@ -5535,7 +5579,7 @@
       <p:grpSpPr/>
       <p:pic>
         <p:nvPicPr>
-          <p:cNvPr id="2" name="Picture 1" descr="03. UI dễ dùng, dữ liệu có kiểm soát."/>
+          <p:cNvPr id="2" name="Picture 1" descr="03. Một thao tác, giao diện phản hồi."/>
           <p:cNvPicPr>
             <a:picLocks noChangeAspect="1"/>
           </p:cNvPicPr>
@@ -5562,6 +5606,9 @@
   <p:clrMapOvr>
     <a:masterClrMapping/>
   </p:clrMapOvr>
+  <p:transition spd="med">
+    <p:fade/>
+  </p:transition>
 </p:sld>
 </file>
 
@@ -5577,7 +5624,7 @@
       <p:grpSpPr/>
       <p:pic>
         <p:nvPicPr>
-          <p:cNvPr id="2" name="Picture 1" descr="04. Một API, nhiều lớp kiểm soát."/>
+          <p:cNvPr id="2" name="Picture 1" descr="04. Không tin request chỉ vì nó đến từ UI."/>
           <p:cNvPicPr>
             <a:picLocks noChangeAspect="1"/>
           </p:cNvPicPr>
@@ -5604,6 +5651,9 @@
   <p:clrMapOvr>
     <a:masterClrMapping/>
   </p:clrMapOvr>
+  <p:transition spd="med">
+    <p:fade/>
+  </p:transition>
 </p:sld>
 </file>
 
@@ -5619,7 +5669,7 @@
       <p:grpSpPr/>
       <p:pic>
         <p:nvPicPr>
-          <p:cNvPr id="2" name="Picture 1" descr="05. Đăng nhập đúng, vào đúng workspace."/>
+          <p:cNvPr id="2" name="Picture 1" descr="05. Đăng nhập ≠ có quyền ghi."/>
           <p:cNvPicPr>
             <a:picLocks noChangeAspect="1"/>
           </p:cNvPicPr>
@@ -5646,6 +5696,9 @@
   <p:clrMapOvr>
     <a:masterClrMapping/>
   </p:clrMapOvr>
+  <p:transition spd="med">
+    <p:fade/>
+  </p:transition>
 </p:sld>
 </file>
 
@@ -5661,7 +5714,7 @@
       <p:grpSpPr/>
       <p:pic>
         <p:nvPicPr>
-          <p:cNvPr id="2" name="Picture 1" descr="06. Dữ liệu quan hệ và vector, cùng một nền."/>
+          <p:cNvPr id="2" name="Picture 1" descr="06. Dữ liệu quan hệ. Vector. Cùng PostgreSQL."/>
           <p:cNvPicPr>
             <a:picLocks noChangeAspect="1"/>
           </p:cNvPicPr>
@@ -5688,6 +5741,9 @@
   <p:clrMapOvr>
     <a:masterClrMapping/>
   </p:clrMapOvr>
+  <p:transition spd="med">
+    <p:fade/>
+  </p:transition>
 </p:sld>
 </file>
 
@@ -5703,7 +5759,7 @@
       <p:grpSpPr/>
       <p:pic>
         <p:nvPicPr>
-          <p:cNvPr id="2" name="Picture 1" descr="07. Không đưa cả PDF vào mọi câu hỏi."/>
+          <p:cNvPr id="2" name="Picture 1" descr="07. PDF trở thành bằng chứng có thể tìm."/>
           <p:cNvPicPr>
             <a:picLocks noChangeAspect="1"/>
           </p:cNvPicPr>
@@ -5730,6 +5786,9 @@
   <p:clrMapOvr>
     <a:masterClrMapping/>
   </p:clrMapOvr>
+  <p:transition spd="med">
+    <p:fade/>
+  </p:transition>
 </p:sld>
 </file>
 
@@ -5745,7 +5804,7 @@
       <p:grpSpPr/>
       <p:pic>
         <p:nvPicPr>
-          <p:cNvPr id="2" name="Picture 1" descr="08. Tìm đúng nguồn trước khi tạo câu trả lời."/>
+          <p:cNvPr id="2" name="Picture 1" descr="08. Tìm đúng nguồn. Rồi mới trả lời."/>
           <p:cNvPicPr>
             <a:picLocks noChangeAspect="1"/>
           </p:cNvPicPr>
@@ -5772,6 +5831,9 @@
   <p:clrMapOvr>
     <a:masterClrMapping/>
   </p:clrMapOvr>
+  <p:transition spd="med">
+    <p:fade/>
+  </p:transition>
 </p:sld>
 </file>
 
@@ -5787,7 +5849,7 @@
       <p:grpSpPr/>
       <p:pic>
         <p:nvPicPr>
-          <p:cNvPr id="2" name="Picture 1" descr="09. JSON đúng cú pháp vẫn chưa đủ."/>
+          <p:cNvPr id="2" name="Picture 1" descr="09. Đầu ra có cấu trúc, dùng được trong app."/>
           <p:cNvPicPr>
             <a:picLocks noChangeAspect="1"/>
           </p:cNvPicPr>
@@ -5814,6 +5876,9 @@
   <p:clrMapOvr>
     <a:masterClrMapping/>
   </p:clrMapOvr>
+  <p:transition spd="med">
+    <p:fade/>
+  </p:transition>
 </p:sld>
 </file>
 

</xml_diff>

<commit_message>
docs: condense technology presentation to ten slides
</commit_message>
<xml_diff>
--- a/docs/submission/ExaMate-Technologies-VI-20261026.pptx
+++ b/docs/submission/ExaMate-Technologies-VI-20261026.pptx
@@ -15,11 +15,6 @@
     <p:sldId id="263" r:id="rId15"/>
     <p:sldId id="264" r:id="rId16"/>
     <p:sldId id="265" r:id="rId17"/>
-    <p:sldId id="266" r:id="rId18"/>
-    <p:sldId id="267" r:id="rId19"/>
-    <p:sldId id="268" r:id="rId20"/>
-    <p:sldId id="269" r:id="rId21"/>
-    <p:sldId id="270" r:id="rId22"/>
   </p:sldIdLst>
   <p:sldSz cx="12191999" cy="6858000" type="screen4x3"/>
   <p:notesSz cx="6858000" cy="9144000"/>
@@ -627,596 +622,6 @@
           </a:p>
           <a:p>
             <a:r>
-              <a:t>Tài · 50 giây “Generation không tự lưu bộ quiz/thẻ. Confirm riêng</a:t>
-            </a:r>
-          </a:p>
-          <a:p>
-            <a:r>
-              <a:t>            mới tạo snapshot cá nhân. Khi nộp bài, server đọc answer key chứ</a:t>
-            </a:r>
-          </a:p>
-          <a:p>
-            <a:r>
-              <a:t>            không nhận score client. Flashcards lưu remembered/needs_review,</a:t>
-            </a:r>
-          </a:p>
-          <a:p>
-            <a:r>
-              <a:t>            không chứng minh đã thành thạo. Nếu mất ACK sau commit thì retry</a:t>
-            </a:r>
-          </a:p>
-          <a:p>
-            <a:r>
-              <a:t>            cùng key/payload, không tạo lượt mới để thoát lỗi; confirm unknown</a:t>
-            </a:r>
-          </a:p>
-          <a:p>
-            <a:r>
-              <a:t>            cần GET trước.” Bộ đã lưu mặc định 90 ngày, nguồn xóa báo</a:t>
-            </a:r>
-          </a:p>
-          <a:p>
-            <a:r>
-              <a:t>            unavailable, manager không đọc của người khác. Code:</a:t>
-            </a:r>
-          </a:p>
-          <a:p>
-            <a:r>
-              <a:t>            StudyCoachPanel.tsx, StudyFlashcardsPanel.tsx,</a:t>
-            </a:r>
-          </a:p>
-          <a:p>
-            <a:r>
-              <a:t>            study-coach.service.ts, study-flashcards.service.ts.</a:t>
-            </a:r>
-          </a:p>
-          <a:p/>
-          <a:p>
-            <a:r>
-              <a:t>Bố cục cố định từ PDF; chỉnh nội dung trong technology.html/CSS rồi dựng lại.</a:t>
-            </a:r>
-          </a:p>
-        </p:txBody>
-      </p:sp>
-      <p:sp>
-        <p:nvSpPr>
-          <p:cNvPr id="4" name="Slide Number Placeholder 3"/>
-          <p:cNvSpPr>
-            <a:spLocks noGrp="1"/>
-          </p:cNvSpPr>
-          <p:nvPr>
-            <p:ph type="sldNum" idx="5" sz="quarter"/>
-          </p:nvPr>
-        </p:nvSpPr>
-        <p:spPr/>
-      </p:sp>
-    </p:spTree>
-  </p:cSld>
-  <p:clrMapOvr>
-    <a:masterClrMapping/>
-  </p:clrMapOvr>
-</p:notes>
-</file>
-
-<file path=ppt/notesSlides/notesSlide11.xml><?xml version="1.0" encoding="utf-8"?>
-<p:notes xmlns:a="http://schemas.openxmlformats.org/drawingml/2006/main" xmlns:p="http://schemas.openxmlformats.org/presentationml/2006/main" xmlns:r="http://schemas.openxmlformats.org/officeDocument/2006/relationships">
-  <p:cSld>
-    <p:spTree>
-      <p:nvGrpSpPr>
-        <p:cNvPr id="1" name=""/>
-        <p:cNvGrpSpPr/>
-        <p:nvPr/>
-      </p:nvGrpSpPr>
-      <p:grpSpPr>
-        <a:xfrm>
-          <a:off x="0" y="0"/>
-          <a:ext cx="0" cy="0"/>
-          <a:chOff x="0" y="0"/>
-          <a:chExt cx="0" cy="0"/>
-        </a:xfrm>
-      </p:grpSpPr>
-      <p:sp>
-        <p:nvSpPr>
-          <p:cNvPr id="2" name="Slide Image Placeholder 1"/>
-          <p:cNvSpPr>
-            <a:spLocks noGrp="1"/>
-          </p:cNvSpPr>
-          <p:nvPr>
-            <p:ph type="sldImg" idx="2"/>
-          </p:nvPr>
-        </p:nvSpPr>
-        <p:spPr/>
-      </p:sp>
-      <p:sp>
-        <p:nvSpPr>
-          <p:cNvPr id="3" name="Notes Placeholder 2"/>
-          <p:cNvSpPr>
-            <a:spLocks noGrp="1"/>
-          </p:cNvSpPr>
-          <p:nvPr>
-            <p:ph type="body" idx="3" sz="quarter"/>
-          </p:nvPr>
-        </p:nvSpPr>
-        <p:spPr/>
-        <p:txBody>
-          <a:bodyPr/>
-          <a:lstStyle/>
-          <a:p>
-            <a:r>
-              <a:t>Lời thuyết trình và điểm chỉ code</a:t>
-            </a:r>
-          </a:p>
-          <a:p>
-            <a:r>
-              <a:t>Thắng · SSE 35 giây; Tài · history 15 giây “SSE không bắt buộc</a:t>
-            </a:r>
-          </a:p>
-          <a:p>
-            <a:r>
-              <a:t>            EventSource. Nhóm cần POST body và CSRF headers nên dùng</a:t>
-            </a:r>
-          </a:p>
-          <a:p>
-            <a:r>
-              <a:t>            fetch/ReadableStream. Một network chunk không bằng một event; parser</a:t>
-            </a:r>
-          </a:p>
-          <a:p>
-            <a:r>
-              <a:t>            phải giữ buffer. General được phát delta, RAG giữ nội dung tới khi</a:t>
-            </a:r>
-          </a:p>
-          <a:p>
-            <a:r>
-              <a:t>            validator xong, không bỏ SSE toàn ứng dụng.” Tài bổ sung: receipt</a:t>
-            </a:r>
-          </a:p>
-          <a:p>
-            <a:r>
-              <a:t>            xác minh snapshot, không chứng minh answer đúng; history mở lại và</a:t>
-            </a:r>
-          </a:p>
-          <a:p>
-            <a:r>
-              <a:t>            follow-up không trộn source cũ thành evidence mới. Epoch/revision</a:t>
-            </a:r>
-          </a:p>
-          <a:p>
-            <a:r>
-              <a:t>            ngăn stream A cập nhật B.</a:t>
-            </a:r>
-          </a:p>
-          <a:p/>
-          <a:p>
-            <a:r>
-              <a:t>Bố cục cố định từ PDF; chỉnh nội dung trong technology.html/CSS rồi dựng lại.</a:t>
-            </a:r>
-          </a:p>
-        </p:txBody>
-      </p:sp>
-      <p:sp>
-        <p:nvSpPr>
-          <p:cNvPr id="4" name="Slide Number Placeholder 3"/>
-          <p:cNvSpPr>
-            <a:spLocks noGrp="1"/>
-          </p:cNvSpPr>
-          <p:nvPr>
-            <p:ph type="sldNum" idx="5" sz="quarter"/>
-          </p:nvPr>
-        </p:nvSpPr>
-        <p:spPr/>
-      </p:sp>
-    </p:spTree>
-  </p:cSld>
-  <p:clrMapOvr>
-    <a:masterClrMapping/>
-  </p:clrMapOvr>
-</p:notes>
-</file>
-
-<file path=ppt/notesSlides/notesSlide12.xml><?xml version="1.0" encoding="utf-8"?>
-<p:notes xmlns:a="http://schemas.openxmlformats.org/drawingml/2006/main" xmlns:p="http://schemas.openxmlformats.org/presentationml/2006/main" xmlns:r="http://schemas.openxmlformats.org/officeDocument/2006/relationships">
-  <p:cSld>
-    <p:spTree>
-      <p:nvGrpSpPr>
-        <p:cNvPr id="1" name=""/>
-        <p:cNvGrpSpPr/>
-        <p:nvPr/>
-      </p:nvGrpSpPr>
-      <p:grpSpPr>
-        <a:xfrm>
-          <a:off x="0" y="0"/>
-          <a:ext cx="0" cy="0"/>
-          <a:chOff x="0" y="0"/>
-          <a:chExt cx="0" cy="0"/>
-        </a:xfrm>
-      </p:grpSpPr>
-      <p:sp>
-        <p:nvSpPr>
-          <p:cNvPr id="2" name="Slide Image Placeholder 1"/>
-          <p:cNvSpPr>
-            <a:spLocks noGrp="1"/>
-          </p:cNvSpPr>
-          <p:nvPr>
-            <p:ph type="sldImg" idx="2"/>
-          </p:nvPr>
-        </p:nvSpPr>
-        <p:spPr/>
-      </p:sp>
-      <p:sp>
-        <p:nvSpPr>
-          <p:cNvPr id="3" name="Notes Placeholder 2"/>
-          <p:cNvSpPr>
-            <a:spLocks noGrp="1"/>
-          </p:cNvSpPr>
-          <p:nvPr>
-            <p:ph type="body" idx="3" sz="quarter"/>
-          </p:nvPr>
-        </p:nvSpPr>
-        <p:spPr/>
-        <p:txBody>
-          <a:bodyPr/>
-          <a:lstStyle/>
-          <a:p>
-            <a:r>
-              <a:t>Lời thuyết trình và điểm chỉ code</a:t>
-            </a:r>
-          </a:p>
-          <a:p>
-            <a:r>
-              <a:t>Thắng · 50 giây “Whisper pretrained chạy trên API host, không trong</a:t>
-            </a:r>
-          </a:p>
-          <a:p>
-            <a:r>
-              <a:t>            browser và không do nhóm train. ONNX là định dạng/runtime; q8 giảm</a:t>
-            </a:r>
-          </a:p>
-          <a:p>
-            <a:r>
-              <a:t>            tài nguyên nhưng có trade-off. Audio dài trong trần 60 giây dùng</a:t>
-            </a:r>
-          </a:p>
-          <a:p>
-            <a:r>
-              <a:t>            chunk 30/stride 5 để không chỉ đọc cửa sổ đầu. Timeout phải</a:t>
-            </a:r>
-          </a:p>
-          <a:p>
-            <a:r>
-              <a:t>            terminate worker/subprocess và cleanup, không chỉ Promise.race.”</a:t>
-            </a:r>
-          </a:p>
-          <a:p>
-            <a:r>
-              <a:t>            Không gọi toàn app offline: Supabase/Gemini vẫn cần mạng. Code:</a:t>
-            </a:r>
-          </a:p>
-          <a:p>
-            <a:r>
-              <a:t>            audio-inspector.ts, local-inference-options.ts,</a:t>
-            </a:r>
-          </a:p>
-          <a:p>
-            <a:r>
-              <a:t>            local-speech-runtime.ts, use-speech-input.ts.</a:t>
-            </a:r>
-          </a:p>
-          <a:p/>
-          <a:p>
-            <a:r>
-              <a:t>Bố cục cố định từ PDF; chỉnh nội dung trong technology.html/CSS rồi dựng lại.</a:t>
-            </a:r>
-          </a:p>
-        </p:txBody>
-      </p:sp>
-      <p:sp>
-        <p:nvSpPr>
-          <p:cNvPr id="4" name="Slide Number Placeholder 3"/>
-          <p:cNvSpPr>
-            <a:spLocks noGrp="1"/>
-          </p:cNvSpPr>
-          <p:nvPr>
-            <p:ph type="sldNum" idx="5" sz="quarter"/>
-          </p:nvPr>
-        </p:nvSpPr>
-        <p:spPr/>
-      </p:sp>
-    </p:spTree>
-  </p:cSld>
-  <p:clrMapOvr>
-    <a:masterClrMapping/>
-  </p:clrMapOvr>
-</p:notes>
-</file>
-
-<file path=ppt/notesSlides/notesSlide13.xml><?xml version="1.0" encoding="utf-8"?>
-<p:notes xmlns:a="http://schemas.openxmlformats.org/drawingml/2006/main" xmlns:p="http://schemas.openxmlformats.org/presentationml/2006/main" xmlns:r="http://schemas.openxmlformats.org/officeDocument/2006/relationships">
-  <p:cSld>
-    <p:spTree>
-      <p:nvGrpSpPr>
-        <p:cNvPr id="1" name=""/>
-        <p:cNvGrpSpPr/>
-        <p:nvPr/>
-      </p:nvGrpSpPr>
-      <p:grpSpPr>
-        <a:xfrm>
-          <a:off x="0" y="0"/>
-          <a:ext cx="0" cy="0"/>
-          <a:chOff x="0" y="0"/>
-          <a:chExt cx="0" cy="0"/>
-        </a:xfrm>
-      </p:grpSpPr>
-      <p:sp>
-        <p:nvSpPr>
-          <p:cNvPr id="2" name="Slide Image Placeholder 1"/>
-          <p:cNvSpPr>
-            <a:spLocks noGrp="1"/>
-          </p:cNvSpPr>
-          <p:nvPr>
-            <p:ph type="sldImg" idx="2"/>
-          </p:nvPr>
-        </p:nvSpPr>
-        <p:spPr/>
-      </p:sp>
-      <p:sp>
-        <p:nvSpPr>
-          <p:cNvPr id="3" name="Notes Placeholder 2"/>
-          <p:cNvSpPr>
-            <a:spLocks noGrp="1"/>
-          </p:cNvSpPr>
-          <p:nvPr>
-            <p:ph type="body" idx="3" sz="quarter"/>
-          </p:nvPr>
-        </p:nvSpPr>
-        <p:spPr/>
-        <p:txBody>
-          <a:bodyPr/>
-          <a:lstStyle/>
-          <a:p>
-            <a:r>
-              <a:t>Lời thuyết trình và điểm chỉ code</a:t>
-            </a:r>
-          </a:p>
-          <a:p>
-            <a:r>
-              <a:t>Tài · 45 giây “Telemetry ghi sau không ngăn chi phí đã xảy ra, nên</a:t>
-            </a:r>
-          </a:p>
-          <a:p>
-            <a:r>
-              <a:t>            admission reserve trước provider. Một RAG request có thể có</a:t>
-            </a:r>
-          </a:p>
-          <a:p>
-            <a:r>
-              <a:t>            embedding và generation; chỉ đếm HTTP request là thiếu. Token null</a:t>
-            </a:r>
-          </a:p>
-          <a:p>
-            <a:r>
-              <a:t>            không coi là zero, cộng decimal/BIGINT không dùng Number tùy tiện.</a:t>
-            </a:r>
-          </a:p>
-          <a:p>
-            <a:r>
-              <a:t>            Dashboard chỉ manager và membership được kiểm mới trong</a:t>
-            </a:r>
-          </a:p>
-          <a:p>
-            <a:r>
-              <a:t>            transaction.” Refresh dùng generation chung cho</a:t>
-            </a:r>
-          </a:p>
-          <a:p>
-            <a:r>
-              <a:t>            overview/cost/detail; chuyển page operation không ép đọc cost nếu</a:t>
-            </a:r>
-          </a:p>
-          <a:p>
-            <a:r>
-              <a:t>            cohort giữ nguyên. Code: ai-admission.service.ts,</a:t>
-            </a:r>
-          </a:p>
-          <a:p>
-            <a:r>
-              <a:t>            ai-usage.service.ts, ai-usage-dashboard.service.ts.</a:t>
-            </a:r>
-          </a:p>
-          <a:p/>
-          <a:p>
-            <a:r>
-              <a:t>Bố cục cố định từ PDF; chỉnh nội dung trong technology.html/CSS rồi dựng lại.</a:t>
-            </a:r>
-          </a:p>
-        </p:txBody>
-      </p:sp>
-      <p:sp>
-        <p:nvSpPr>
-          <p:cNvPr id="4" name="Slide Number Placeholder 3"/>
-          <p:cNvSpPr>
-            <a:spLocks noGrp="1"/>
-          </p:cNvSpPr>
-          <p:nvPr>
-            <p:ph type="sldNum" idx="5" sz="quarter"/>
-          </p:nvPr>
-        </p:nvSpPr>
-        <p:spPr/>
-      </p:sp>
-    </p:spTree>
-  </p:cSld>
-  <p:clrMapOvr>
-    <a:masterClrMapping/>
-  </p:clrMapOvr>
-</p:notes>
-</file>
-
-<file path=ppt/notesSlides/notesSlide14.xml><?xml version="1.0" encoding="utf-8"?>
-<p:notes xmlns:a="http://schemas.openxmlformats.org/drawingml/2006/main" xmlns:p="http://schemas.openxmlformats.org/presentationml/2006/main" xmlns:r="http://schemas.openxmlformats.org/officeDocument/2006/relationships">
-  <p:cSld>
-    <p:spTree>
-      <p:nvGrpSpPr>
-        <p:cNvPr id="1" name=""/>
-        <p:cNvGrpSpPr/>
-        <p:nvPr/>
-      </p:nvGrpSpPr>
-      <p:grpSpPr>
-        <a:xfrm>
-          <a:off x="0" y="0"/>
-          <a:ext cx="0" cy="0"/>
-          <a:chOff x="0" y="0"/>
-          <a:chExt cx="0" cy="0"/>
-        </a:xfrm>
-      </p:grpSpPr>
-      <p:sp>
-        <p:nvSpPr>
-          <p:cNvPr id="2" name="Slide Image Placeholder 1"/>
-          <p:cNvSpPr>
-            <a:spLocks noGrp="1"/>
-          </p:cNvSpPr>
-          <p:nvPr>
-            <p:ph type="sldImg" idx="2"/>
-          </p:nvPr>
-        </p:nvSpPr>
-        <p:spPr/>
-      </p:sp>
-      <p:sp>
-        <p:nvSpPr>
-          <p:cNvPr id="3" name="Notes Placeholder 2"/>
-          <p:cNvSpPr>
-            <a:spLocks noGrp="1"/>
-          </p:cNvSpPr>
-          <p:nvPr>
-            <p:ph type="body" idx="3" sz="quarter"/>
-          </p:nvPr>
-        </p:nvSpPr>
-        <p:spPr/>
-        <p:txBody>
-          <a:bodyPr/>
-          <a:lstStyle/>
-          <a:p>
-            <a:r>
-              <a:t>Lời thuyết trình và điểm chỉ code</a:t>
-            </a:r>
-          </a:p>
-          <a:p>
-            <a:r>
-              <a:t>Tài · 40 giây “Container chỉ đóng gói ứng dụng, không tự làm</a:t>
-            </a:r>
-          </a:p>
-          <a:p>
-            <a:r>
-              <a:t>            Auth/Storage/Gemini offline. Dữ liệu bền do DB/Storage, không vì</a:t>
-            </a:r>
-          </a:p>
-          <a:p>
-            <a:r>
-              <a:t>            state React hay image Docker. nginx giữ proxy/Origin và không buffer</a:t>
-            </a:r>
-          </a:p>
-          <a:p>
-            <a:r>
-              <a:t>            SSE; TLS CA phải được giữ, không tắt kiểm chứng để kết nối.” Không</a:t>
-            </a:r>
-          </a:p>
-          <a:p>
-            <a:r>
-              <a:t>            trình chiếu .env, không chạy lại migration/cloud write khi chỉ khởi</a:t>
-            </a:r>
-          </a:p>
-          <a:p>
-            <a:r>
-              <a:t>            động demo. Đây là mô tả deployment đã lưu, không một đợt triển khai</a:t>
-            </a:r>
-          </a:p>
-          <a:p>
-            <a:r>
-              <a:t>            mới. Code: compose.yaml, compose.ca.yaml, Dockerfiles và</a:t>
-            </a:r>
-          </a:p>
-          <a:p>
-            <a:r>
-              <a:t>            infra/nginx/default.conf.</a:t>
-            </a:r>
-          </a:p>
-          <a:p/>
-          <a:p>
-            <a:r>
-              <a:t>Bố cục cố định từ PDF; chỉnh nội dung trong technology.html/CSS rồi dựng lại.</a:t>
-            </a:r>
-          </a:p>
-        </p:txBody>
-      </p:sp>
-      <p:sp>
-        <p:nvSpPr>
-          <p:cNvPr id="4" name="Slide Number Placeholder 3"/>
-          <p:cNvSpPr>
-            <a:spLocks noGrp="1"/>
-          </p:cNvSpPr>
-          <p:nvPr>
-            <p:ph type="sldNum" idx="5" sz="quarter"/>
-          </p:nvPr>
-        </p:nvSpPr>
-        <p:spPr/>
-      </p:sp>
-    </p:spTree>
-  </p:cSld>
-  <p:clrMapOvr>
-    <a:masterClrMapping/>
-  </p:clrMapOvr>
-</p:notes>
-</file>
-
-<file path=ppt/notesSlides/notesSlide15.xml><?xml version="1.0" encoding="utf-8"?>
-<p:notes xmlns:a="http://schemas.openxmlformats.org/drawingml/2006/main" xmlns:p="http://schemas.openxmlformats.org/presentationml/2006/main" xmlns:r="http://schemas.openxmlformats.org/officeDocument/2006/relationships">
-  <p:cSld>
-    <p:spTree>
-      <p:nvGrpSpPr>
-        <p:cNvPr id="1" name=""/>
-        <p:cNvGrpSpPr/>
-        <p:nvPr/>
-      </p:nvGrpSpPr>
-      <p:grpSpPr>
-        <a:xfrm>
-          <a:off x="0" y="0"/>
-          <a:ext cx="0" cy="0"/>
-          <a:chOff x="0" y="0"/>
-          <a:chExt cx="0" cy="0"/>
-        </a:xfrm>
-      </p:grpSpPr>
-      <p:sp>
-        <p:nvSpPr>
-          <p:cNvPr id="2" name="Slide Image Placeholder 1"/>
-          <p:cNvSpPr>
-            <a:spLocks noGrp="1"/>
-          </p:cNvSpPr>
-          <p:nvPr>
-            <p:ph type="sldImg" idx="2"/>
-          </p:nvPr>
-        </p:nvSpPr>
-        <p:spPr/>
-      </p:sp>
-      <p:sp>
-        <p:nvSpPr>
-          <p:cNvPr id="3" name="Notes Placeholder 2"/>
-          <p:cNvSpPr>
-            <a:spLocks noGrp="1"/>
-          </p:cNvSpPr>
-          <p:nvPr>
-            <p:ph type="body" idx="3" sz="quarter"/>
-          </p:nvPr>
-        </p:nvSpPr>
-        <p:spPr/>
-        <p:txBody>
-          <a:bodyPr/>
-          <a:lstStyle/>
-          <a:p>
-            <a:r>
-              <a:t>Lời thuyết trình và điểm chỉ code</a:t>
-            </a:r>
-          </a:p>
-          <a:p>
-            <a:r>
               <a:t>Cả hai · kết 40 giây “Không lớp test nào tự chứng minh mọi câu AI</a:t>
             </a:r>
           </a:p>
@@ -1371,6 +776,51 @@
               <a:t>            app.module.ts, database.service.ts, compose.yaml.</a:t>
             </a:r>
           </a:p>
+          <a:p>
+            <a:r>
+              <a:t>Phần đã gộp: Không tin request chỉ vì nó đến từ UI.</a:t>
+            </a:r>
+          </a:p>
+          <a:p>
+            <a:r>
+              <a:t>Thắng · 40 giây “Thắng đóng góp nền backend/Supabase và Gemini ban</a:t>
+            </a:r>
+          </a:p>
+          <a:p>
+            <a:r>
+              <a:t>            đầu; Tài tích hợp tiếp Auth/RLS và nghiệp vụ. Nest giúp controller</a:t>
+            </a:r>
+          </a:p>
+          <a:p>
+            <a:r>
+              <a:t>            không chứa cả pipeline AI. DI cho phép test giả SDK/Auth upstream</a:t>
+            </a:r>
+          </a:p>
+          <a:p>
+            <a:r>
+              <a:t>            trong khi Nest, authorization, service và PostgreSQL vẫn thật.”</a:t>
+            </a:r>
+          </a:p>
+          <a:p>
+            <a:r>
+              <a:t>            Code: assistant.controller.ts, auth.guard.ts, common/http.ts,</a:t>
+            </a:r>
+          </a:p>
+          <a:p>
+            <a:r>
+              <a:t>            packages/contracts/index.d.ts. TypeScript type bị xóa khi compile,</a:t>
+            </a:r>
+          </a:p>
+          <a:p>
+            <a:r>
+              <a:t>            nên body từ mạng phải validate. Không nối sort identifier từ client;</a:t>
+            </a:r>
+          </a:p>
+          <a:p>
+            <a:r>
+              <a:t>            dùng allowlist.</a:t>
+            </a:r>
+          </a:p>
           <a:p/>
           <a:p>
             <a:r>
@@ -1570,42 +1020,92 @@
           </a:p>
           <a:p>
             <a:r>
-              <a:t>Thắng · 40 giây “Thắng đóng góp nền backend/Supabase và Gemini ban</a:t>
-            </a:r>
-          </a:p>
-          <a:p>
-            <a:r>
-              <a:t>            đầu; Tài tích hợp tiếp Auth/RLS và nghiệp vụ. Nest giúp controller</a:t>
-            </a:r>
-          </a:p>
-          <a:p>
-            <a:r>
-              <a:t>            không chứa cả pipeline AI. DI cho phép test giả SDK/Auth upstream</a:t>
-            </a:r>
-          </a:p>
-          <a:p>
-            <a:r>
-              <a:t>            trong khi Nest, authorization, service và PostgreSQL vẫn thật.”</a:t>
-            </a:r>
-          </a:p>
-          <a:p>
-            <a:r>
-              <a:t>            Code: assistant.controller.ts, auth.guard.ts, common/http.ts,</a:t>
-            </a:r>
-          </a:p>
-          <a:p>
-            <a:r>
-              <a:t>            packages/contracts/index.d.ts. TypeScript type bị xóa khi compile,</a:t>
-            </a:r>
-          </a:p>
-          <a:p>
-            <a:r>
-              <a:t>            nên body từ mạng phải validate. Không nối sort identifier từ client;</a:t>
-            </a:r>
-          </a:p>
-          <a:p>
-            <a:r>
-              <a:t>            dùng allowlist.</a:t>
+              <a:t>Tài · 45 giây “Authentication trả lời bạn là ai, authorization trả</a:t>
+            </a:r>
+          </a:p>
+          <a:p>
+            <a:r>
+              <a:t>            lời bạn được làm gì. Phiên opaque HttpOnly khác JWT: browser không</a:t>
+            </a:r>
+          </a:p>
+          <a:p>
+            <a:r>
+              <a:t>            tự giữ access token trong localStorage. Mỗi workspace request dùng</a:t>
+            </a:r>
+          </a:p>
+          <a:p>
+            <a:r>
+              <a:t>            principal server xác minh; viewer không ghi dù sửa DOM. Manager cũng</a:t>
+            </a:r>
+          </a:p>
+          <a:p>
+            <a:r>
+              <a:t>            không đọc hội thoại/quiz riêng của người khác.” Google callback về</a:t>
+            </a:r>
+          </a:p>
+          <a:p>
+            <a:r>
+              <a:t>            Supabase khác callback về app. Code: auth.service.ts, auth.guard.ts,</a:t>
+            </a:r>
+          </a:p>
+          <a:p>
+            <a:r>
+              <a:t>            use-pilot-session.ts, PilotAccess.tsx. Không chiếu</a:t>
+            </a:r>
+          </a:p>
+          <a:p>
+            <a:r>
+              <a:t>            .env/cookie/token.</a:t>
+            </a:r>
+          </a:p>
+          <a:p>
+            <a:r>
+              <a:t>Phần đã gộp: Dữ liệu quan hệ. Vector. Cùng PostgreSQL.</a:t>
+            </a:r>
+          </a:p>
+          <a:p>
+            <a:r>
+              <a:t>Tài · 45 giây; Thắng nắm nền database “PostgreSQL đáp ứng dữ liệu</a:t>
+            </a:r>
+          </a:p>
+          <a:p>
+            <a:r>
+              <a:t>            quan hệ còn pgvector bổ sung kiểu vector và phép khoảng cách. RLS là</a:t>
+            </a:r>
+          </a:p>
+          <a:p>
+            <a:r>
+              <a:t>            lớp DB, WHERE là scope ứng dụng; dùng cả hai. Runtime</a:t>
+            </a:r>
+          </a:p>
+          <a:p>
+            <a:r>
+              <a:t>            owner/BYPASSRLS sẽ làm mất ý nghĩa bảo vệ nên nhóm tách LOGIN</a:t>
+            </a:r>
+          </a:p>
+          <a:p>
+            <a:r>
+              <a:t>            business/Auth. Context transaction-local tránh rò pool giữa</a:t>
+            </a:r>
+          </a:p>
+          <a:p>
+            <a:r>
+              <a:t>            request.” Giải thích score 1 − cosine distance không là xác suất</a:t>
+            </a:r>
+          </a:p>
+          <a:p>
+            <a:r>
+              <a:t>            đúng; không nhận đã tối ưu ANN cho dữ liệu lớn. Code:</a:t>
+            </a:r>
+          </a:p>
+          <a:p>
+            <a:r>
+              <a:t>            database.service.ts, runtime-capability-contract.ts,</a:t>
+            </a:r>
+          </a:p>
+          <a:p>
+            <a:r>
+              <a:t>            rag-retrieval.service.ts.</a:t>
             </a:r>
           </a:p>
           <a:p/>
@@ -1686,42 +1186,97 @@
           </a:p>
           <a:p>
             <a:r>
-              <a:t>Tài · 45 giây “Authentication trả lời bạn là ai, authorization trả</a:t>
-            </a:r>
-          </a:p>
-          <a:p>
-            <a:r>
-              <a:t>            lời bạn được làm gì. Phiên opaque HttpOnly khác JWT: browser không</a:t>
-            </a:r>
-          </a:p>
-          <a:p>
-            <a:r>
-              <a:t>            tự giữ access token trong localStorage. Mỗi workspace request dùng</a:t>
-            </a:r>
-          </a:p>
-          <a:p>
-            <a:r>
-              <a:t>            principal server xác minh; viewer không ghi dù sửa DOM. Manager cũng</a:t>
-            </a:r>
-          </a:p>
-          <a:p>
-            <a:r>
-              <a:t>            không đọc hội thoại/quiz riêng của người khác.” Google callback về</a:t>
-            </a:r>
-          </a:p>
-          <a:p>
-            <a:r>
-              <a:t>            Supabase khác callback về app. Code: auth.service.ts, auth.guard.ts,</a:t>
-            </a:r>
-          </a:p>
-          <a:p>
-            <a:r>
-              <a:t>            use-pilot-session.ts, PilotAccess.tsx. Không chiếu</a:t>
-            </a:r>
-          </a:p>
-          <a:p>
-            <a:r>
-              <a:t>            .env/cookie/token.</a:t>
+              <a:t>Tài + Thắng · 50 giây “RAG không train hay fine-tune; lấy evidence</a:t>
+            </a:r>
+          </a:p>
+          <a:p>
+            <a:r>
+              <a:t>            đúng quyền rồi mới yêu cầu model trả lời. Embedding dùng để so liên</a:t>
+            </a:r>
+          </a:p>
+          <a:p>
+            <a:r>
+              <a:t>            quan, generation mới viết answer. Ngưỡng 0,55 là source default,</a:t>
+            </a:r>
+          </a:p>
+          <a:p>
+            <a:r>
+              <a:t>            không 55% accuracy; runtime có thể khác. Citation map ID về</a:t>
+            </a:r>
+          </a:p>
+          <a:p>
+            <a:r>
+              <a:t>            document/page trên server, nhưng claim grounding còn phải đối</a:t>
+            </a:r>
+          </a:p>
+          <a:p>
+            <a:r>
+              <a:t>            chiếu.” Thắng có đóng góp RAG đã được Tài xác nhận, không gán riêng</a:t>
+            </a:r>
+          </a:p>
+          <a:p>
+            <a:r>
+              <a:t>            toàn bộ cho một người. Code: rag-retrieval.service.ts,</a:t>
+            </a:r>
+          </a:p>
+          <a:p>
+            <a:r>
+              <a:t>            rag-context.ts, source-markers.ts, prompt-registry.ts. Hỏi ngoài PDF</a:t>
+            </a:r>
+          </a:p>
+          <a:p>
+            <a:r>
+              <a:t>            có thể tốn query embedding nhưng không answer generation.</a:t>
+            </a:r>
+          </a:p>
+          <a:p>
+            <a:r>
+              <a:t>Phần đã gộp: PDF trở thành bằng chứng có thể tìm.</a:t>
+            </a:r>
+          </a:p>
+          <a:p>
+            <a:r>
+              <a:t>Thắng + Tài · 45 giây “Nhóm chia theo trang và giữ overlap để giảm</a:t>
+            </a:r>
+          </a:p>
+          <a:p>
+            <a:r>
+              <a:t>            mất ngữ cảnh ở ranh giới. Các số là ký tự, không phải token. Signed</a:t>
+            </a:r>
+          </a:p>
+          <a:p>
+            <a:r>
+              <a:t>            URL được tạo sau authorize, không do model cung cấp. OCR chỉ dành</a:t>
+            </a:r>
+          </a:p>
+          <a:p>
+            <a:r>
+              <a:t>            trang không trích được text hữu ích, không tự chạy lại mọi tài</a:t>
+            </a:r>
+          </a:p>
+          <a:p>
+            <a:r>
+              <a:t>            liệu.” Cấu hình local ngày 26/10 đã đổi riêng GEMINI_OCR_MODEL sang</a:t>
+            </a:r>
+          </a:p>
+          <a:p>
+            <a:r>
+              <a:t>            gemini-3.5-flash-lite nhưng OCR vẫn tắt; source fallback vẫn</a:t>
+            </a:r>
+          </a:p>
+          <a:p>
+            <a:r>
+              <a:t>            2.5-flash. Đó không phải kết quả benchmark OCR hoặc thay model</a:t>
+            </a:r>
+          </a:p>
+          <a:p>
+            <a:r>
+              <a:t>            generation của evaluation. Code: document-ingestion.service.ts,</a:t>
+            </a:r>
+          </a:p>
+          <a:p>
+            <a:r>
+              <a:t>            document-chunker.ts, document-ocr.service.ts.</a:t>
             </a:r>
           </a:p>
           <a:p/>
@@ -1802,47 +1357,97 @@
           </a:p>
           <a:p>
             <a:r>
-              <a:t>Tài · 45 giây; Thắng nắm nền database “PostgreSQL đáp ứng dữ liệu</a:t>
-            </a:r>
-          </a:p>
-          <a:p>
-            <a:r>
-              <a:t>            quan hệ còn pgvector bổ sung kiểu vector và phép khoảng cách. RLS là</a:t>
-            </a:r>
-          </a:p>
-          <a:p>
-            <a:r>
-              <a:t>            lớp DB, WHERE là scope ứng dụng; dùng cả hai. Runtime</a:t>
-            </a:r>
-          </a:p>
-          <a:p>
-            <a:r>
-              <a:t>            owner/BYPASSRLS sẽ làm mất ý nghĩa bảo vệ nên nhóm tách LOGIN</a:t>
-            </a:r>
-          </a:p>
-          <a:p>
-            <a:r>
-              <a:t>            business/Auth. Context transaction-local tránh rò pool giữa</a:t>
-            </a:r>
-          </a:p>
-          <a:p>
-            <a:r>
-              <a:t>            request.” Giải thích score 1 − cosine distance không là xác suất</a:t>
-            </a:r>
-          </a:p>
-          <a:p>
-            <a:r>
-              <a:t>            đúng; không nhận đã tối ưu ANN cho dữ liệu lớn. Code:</a:t>
-            </a:r>
-          </a:p>
-          <a:p>
-            <a:r>
-              <a:t>            database.service.ts, runtime-capability-contract.ts,</a:t>
-            </a:r>
-          </a:p>
-          <a:p>
-            <a:r>
-              <a:t>            rag-retrieval.service.ts.</a:t>
+              <a:t>Tài · 50 giây “Generation không tự lưu bộ quiz/thẻ. Confirm riêng</a:t>
+            </a:r>
+          </a:p>
+          <a:p>
+            <a:r>
+              <a:t>            mới tạo snapshot cá nhân. Khi nộp bài, server đọc answer key chứ</a:t>
+            </a:r>
+          </a:p>
+          <a:p>
+            <a:r>
+              <a:t>            không nhận score client. Flashcards lưu remembered/needs_review,</a:t>
+            </a:r>
+          </a:p>
+          <a:p>
+            <a:r>
+              <a:t>            không chứng minh đã thành thạo. Nếu mất ACK sau commit thì retry</a:t>
+            </a:r>
+          </a:p>
+          <a:p>
+            <a:r>
+              <a:t>            cùng key/payload, không tạo lượt mới để thoát lỗi; confirm unknown</a:t>
+            </a:r>
+          </a:p>
+          <a:p>
+            <a:r>
+              <a:t>            cần GET trước.” Bộ đã lưu mặc định 90 ngày, nguồn xóa báo</a:t>
+            </a:r>
+          </a:p>
+          <a:p>
+            <a:r>
+              <a:t>            unavailable, manager không đọc của người khác. Code:</a:t>
+            </a:r>
+          </a:p>
+          <a:p>
+            <a:r>
+              <a:t>            StudyCoachPanel.tsx, StudyFlashcardsPanel.tsx,</a:t>
+            </a:r>
+          </a:p>
+          <a:p>
+            <a:r>
+              <a:t>            study-coach.service.ts, study-flashcards.service.ts.</a:t>
+            </a:r>
+          </a:p>
+          <a:p>
+            <a:r>
+              <a:t>Phần đã gộp: Đầu ra có cấu trúc, dùng được trong app.</a:t>
+            </a:r>
+          </a:p>
+          <a:p>
+            <a:r>
+              <a:t>Tài · 45 giây “Nhóm chọn Gemini qua wrapper đang có, hỗ trợ</a:t>
+            </a:r>
+          </a:p>
+          <a:p>
+            <a:r>
+              <a:t>            generation và structured output. Không nói model chắc tốt nhất khi</a:t>
+            </a:r>
+          </a:p>
+          <a:p>
+            <a:r>
+              <a:t>            chưa so sánh. responseJsonSchema giúp định dạng nhưng server vẫn</a:t>
+            </a:r>
+          </a:p>
+          <a:p>
+            <a:r>
+              <a:t>            validate lại, reject JSON lỗi/truncated, thừa field, trùng câu/thẻ</a:t>
+            </a:r>
+          </a:p>
+          <a:p>
+            <a:r>
+              <a:t>            hoặc source giả. Answer key đúng kiểu chưa đồng nghĩa đúng kiến</a:t>
+            </a:r>
+          </a:p>
+          <a:p>
+            <a:r>
+              <a:t>            thức.” Model generation do GEMINI_MODEL quyết định; baseline giữ</a:t>
+            </a:r>
+          </a:p>
+          <a:p>
+            <a:r>
+              <a:t>            gemini-2.5-flash, template và OCR riêng có thể khác. Code:</a:t>
+            </a:r>
+          </a:p>
+          <a:p>
+            <a:r>
+              <a:t>            gemini.service.ts, prompt-registry.ts, study-quiz-validation.ts,</a:t>
+            </a:r>
+          </a:p>
+          <a:p>
+            <a:r>
+              <a:t>            study-flashcards-validation.ts.</a:t>
             </a:r>
           </a:p>
           <a:p/>
@@ -1923,47 +1528,87 @@
           </a:p>
           <a:p>
             <a:r>
-              <a:t>Thắng + Tài · 45 giây “Nhóm chia theo trang và giữ overlap để giảm</a:t>
-            </a:r>
-          </a:p>
-          <a:p>
-            <a:r>
-              <a:t>            mất ngữ cảnh ở ranh giới. Các số là ký tự, không phải token. Signed</a:t>
-            </a:r>
-          </a:p>
-          <a:p>
-            <a:r>
-              <a:t>            URL được tạo sau authorize, không do model cung cấp. OCR chỉ dành</a:t>
-            </a:r>
-          </a:p>
-          <a:p>
-            <a:r>
-              <a:t>            trang không trích được text hữu ích, không tự chạy lại mọi tài</a:t>
-            </a:r>
-          </a:p>
-          <a:p>
-            <a:r>
-              <a:t>            liệu.” Cấu hình local ngày 26/10 đã đổi riêng GEMINI_OCR_MODEL sang</a:t>
-            </a:r>
-          </a:p>
-          <a:p>
-            <a:r>
-              <a:t>            gemini-3.5-flash-lite nhưng OCR vẫn tắt; source fallback vẫn</a:t>
-            </a:r>
-          </a:p>
-          <a:p>
-            <a:r>
-              <a:t>            2.5-flash. Đó không phải kết quả benchmark OCR hoặc thay model</a:t>
-            </a:r>
-          </a:p>
-          <a:p>
-            <a:r>
-              <a:t>            generation của evaluation. Code: document-ingestion.service.ts,</a:t>
-            </a:r>
-          </a:p>
-          <a:p>
-            <a:r>
-              <a:t>            document-chunker.ts, document-ocr.service.ts.</a:t>
+              <a:t>Thắng · SSE 35 giây; Tài · history 15 giây “SSE không bắt buộc</a:t>
+            </a:r>
+          </a:p>
+          <a:p>
+            <a:r>
+              <a:t>            EventSource. Nhóm cần POST body và CSRF headers nên dùng</a:t>
+            </a:r>
+          </a:p>
+          <a:p>
+            <a:r>
+              <a:t>            fetch/ReadableStream. Một network chunk không bằng một event; parser</a:t>
+            </a:r>
+          </a:p>
+          <a:p>
+            <a:r>
+              <a:t>            phải giữ buffer. General được phát delta, RAG giữ nội dung tới khi</a:t>
+            </a:r>
+          </a:p>
+          <a:p>
+            <a:r>
+              <a:t>            validator xong, không bỏ SSE toàn ứng dụng.” Tài bổ sung: receipt</a:t>
+            </a:r>
+          </a:p>
+          <a:p>
+            <a:r>
+              <a:t>            xác minh snapshot, không chứng minh answer đúng; history mở lại và</a:t>
+            </a:r>
+          </a:p>
+          <a:p>
+            <a:r>
+              <a:t>            follow-up không trộn source cũ thành evidence mới. Epoch/revision</a:t>
+            </a:r>
+          </a:p>
+          <a:p>
+            <a:r>
+              <a:t>            ngăn stream A cập nhật B.</a:t>
+            </a:r>
+          </a:p>
+          <a:p>
+            <a:r>
+              <a:t>Phần đã gộp: Nói → sửa bản chép → tự gửi.</a:t>
+            </a:r>
+          </a:p>
+          <a:p>
+            <a:r>
+              <a:t>Thắng · 50 giây “Whisper pretrained chạy trên API host, không trong</a:t>
+            </a:r>
+          </a:p>
+          <a:p>
+            <a:r>
+              <a:t>            browser và không do nhóm train. ONNX là định dạng/runtime; q8 giảm</a:t>
+            </a:r>
+          </a:p>
+          <a:p>
+            <a:r>
+              <a:t>            tài nguyên nhưng có trade-off. Audio dài trong trần 60 giây dùng</a:t>
+            </a:r>
+          </a:p>
+          <a:p>
+            <a:r>
+              <a:t>            chunk 30/stride 5 để không chỉ đọc cửa sổ đầu. Timeout phải</a:t>
+            </a:r>
+          </a:p>
+          <a:p>
+            <a:r>
+              <a:t>            terminate worker/subprocess và cleanup, không chỉ Promise.race.”</a:t>
+            </a:r>
+          </a:p>
+          <a:p>
+            <a:r>
+              <a:t>            Không gọi toàn app offline: Supabase/Gemini vẫn cần mạng. Code:</a:t>
+            </a:r>
+          </a:p>
+          <a:p>
+            <a:r>
+              <a:t>            audio-inspector.ts, local-inference-options.ts,</a:t>
+            </a:r>
+          </a:p>
+          <a:p>
+            <a:r>
+              <a:t>            local-speech-runtime.ts, use-speech-input.ts.</a:t>
             </a:r>
           </a:p>
           <a:p/>
@@ -2044,47 +1689,47 @@
           </a:p>
           <a:p>
             <a:r>
-              <a:t>Tài + Thắng · 50 giây “RAG không train hay fine-tune; lấy evidence</a:t>
-            </a:r>
-          </a:p>
-          <a:p>
-            <a:r>
-              <a:t>            đúng quyền rồi mới yêu cầu model trả lời. Embedding dùng để so liên</a:t>
-            </a:r>
-          </a:p>
-          <a:p>
-            <a:r>
-              <a:t>            quan, generation mới viết answer. Ngưỡng 0,55 là source default,</a:t>
-            </a:r>
-          </a:p>
-          <a:p>
-            <a:r>
-              <a:t>            không 55% accuracy; runtime có thể khác. Citation map ID về</a:t>
-            </a:r>
-          </a:p>
-          <a:p>
-            <a:r>
-              <a:t>            document/page trên server, nhưng claim grounding còn phải đối</a:t>
-            </a:r>
-          </a:p>
-          <a:p>
-            <a:r>
-              <a:t>            chiếu.” Thắng có đóng góp RAG đã được Tài xác nhận, không gán riêng</a:t>
-            </a:r>
-          </a:p>
-          <a:p>
-            <a:r>
-              <a:t>            toàn bộ cho một người. Code: rag-retrieval.service.ts,</a:t>
-            </a:r>
-          </a:p>
-          <a:p>
-            <a:r>
-              <a:t>            rag-context.ts, source-markers.ts, prompt-registry.ts. Hỏi ngoài PDF</a:t>
-            </a:r>
-          </a:p>
-          <a:p>
-            <a:r>
-              <a:t>            có thể tốn query embedding nhưng không answer generation.</a:t>
+              <a:t>Tài · 45 giây “Telemetry ghi sau không ngăn chi phí đã xảy ra, nên</a:t>
+            </a:r>
+          </a:p>
+          <a:p>
+            <a:r>
+              <a:t>            admission reserve trước provider. Một RAG request có thể có</a:t>
+            </a:r>
+          </a:p>
+          <a:p>
+            <a:r>
+              <a:t>            embedding và generation; chỉ đếm HTTP request là thiếu. Token null</a:t>
+            </a:r>
+          </a:p>
+          <a:p>
+            <a:r>
+              <a:t>            không coi là zero, cộng decimal/BIGINT không dùng Number tùy tiện.</a:t>
+            </a:r>
+          </a:p>
+          <a:p>
+            <a:r>
+              <a:t>            Dashboard chỉ manager và membership được kiểm mới trong</a:t>
+            </a:r>
+          </a:p>
+          <a:p>
+            <a:r>
+              <a:t>            transaction.” Refresh dùng generation chung cho</a:t>
+            </a:r>
+          </a:p>
+          <a:p>
+            <a:r>
+              <a:t>            overview/cost/detail; chuyển page operation không ép đọc cost nếu</a:t>
+            </a:r>
+          </a:p>
+          <a:p>
+            <a:r>
+              <a:t>            cohort giữ nguyên. Code: ai-admission.service.ts,</a:t>
+            </a:r>
+          </a:p>
+          <a:p>
+            <a:r>
+              <a:t>            ai-usage.service.ts, ai-usage-dashboard.service.ts.</a:t>
             </a:r>
           </a:p>
           <a:p/>
@@ -2165,47 +1810,42 @@
           </a:p>
           <a:p>
             <a:r>
-              <a:t>Tài · 45 giây “Nhóm chọn Gemini qua wrapper đang có, hỗ trợ</a:t>
-            </a:r>
-          </a:p>
-          <a:p>
-            <a:r>
-              <a:t>            generation và structured output. Không nói model chắc tốt nhất khi</a:t>
-            </a:r>
-          </a:p>
-          <a:p>
-            <a:r>
-              <a:t>            chưa so sánh. responseJsonSchema giúp định dạng nhưng server vẫn</a:t>
-            </a:r>
-          </a:p>
-          <a:p>
-            <a:r>
-              <a:t>            validate lại, reject JSON lỗi/truncated, thừa field, trùng câu/thẻ</a:t>
-            </a:r>
-          </a:p>
-          <a:p>
-            <a:r>
-              <a:t>            hoặc source giả. Answer key đúng kiểu chưa đồng nghĩa đúng kiến</a:t>
-            </a:r>
-          </a:p>
-          <a:p>
-            <a:r>
-              <a:t>            thức.” Model generation do GEMINI_MODEL quyết định; baseline giữ</a:t>
-            </a:r>
-          </a:p>
-          <a:p>
-            <a:r>
-              <a:t>            gemini-2.5-flash, template và OCR riêng có thể khác. Code:</a:t>
-            </a:r>
-          </a:p>
-          <a:p>
-            <a:r>
-              <a:t>            gemini.service.ts, prompt-registry.ts, study-quiz-validation.ts,</a:t>
-            </a:r>
-          </a:p>
-          <a:p>
-            <a:r>
-              <a:t>            study-flashcards-validation.ts.</a:t>
+              <a:t>Tài · 40 giây “Container chỉ đóng gói ứng dụng, không tự làm</a:t>
+            </a:r>
+          </a:p>
+          <a:p>
+            <a:r>
+              <a:t>            Auth/Storage/Gemini offline. Dữ liệu bền do DB/Storage, không vì</a:t>
+            </a:r>
+          </a:p>
+          <a:p>
+            <a:r>
+              <a:t>            state React hay image Docker. nginx giữ proxy/Origin và không buffer</a:t>
+            </a:r>
+          </a:p>
+          <a:p>
+            <a:r>
+              <a:t>            SSE; TLS CA phải được giữ, không tắt kiểm chứng để kết nối.” Không</a:t>
+            </a:r>
+          </a:p>
+          <a:p>
+            <a:r>
+              <a:t>            trình chiếu .env, không chạy lại migration/cloud write khi chỉ khởi</a:t>
+            </a:r>
+          </a:p>
+          <a:p>
+            <a:r>
+              <a:t>            động demo. Đây là mô tả deployment đã lưu, không một đợt triển khai</a:t>
+            </a:r>
+          </a:p>
+          <a:p>
+            <a:r>
+              <a:t>            mới. Code: compose.yaml, compose.ca.yaml, Dockerfiles và</a:t>
+            </a:r>
+          </a:p>
+          <a:p>
+            <a:r>
+              <a:t>            infra/nginx/default.conf.</a:t>
             </a:r>
           </a:p>
           <a:p/>
@@ -5264,232 +4904,7 @@
       <p:grpSpPr/>
       <p:pic>
         <p:nvPicPr>
-          <p:cNvPr id="2" name="Picture 1" descr="10. Học bằng hành động, không chỉ đọc JSON."/>
-          <p:cNvPicPr>
-            <a:picLocks noChangeAspect="1"/>
-          </p:cNvPicPr>
-          <p:nvPr/>
-        </p:nvPicPr>
-        <p:blipFill>
-          <a:blip r:embed="rId2"/>
-          <a:stretch>
-            <a:fillRect/>
-          </a:stretch>
-        </p:blipFill>
-        <p:spPr>
-          <a:xfrm>
-            <a:off x="0" y="0"/>
-            <a:ext cx="12191999" cy="6858000"/>
-          </a:xfrm>
-          <a:prstGeom prst="rect">
-            <a:avLst/>
-          </a:prstGeom>
-        </p:spPr>
-      </p:pic>
-    </p:spTree>
-  </p:cSld>
-  <p:clrMapOvr>
-    <a:masterClrMapping/>
-  </p:clrMapOvr>
-  <p:transition spd="med">
-    <p:fade/>
-  </p:transition>
-</p:sld>
-</file>
-
-<file path=ppt/slides/slide11.xml><?xml version="1.0" encoding="utf-8"?>
-<p:sld xmlns:a="http://schemas.openxmlformats.org/drawingml/2006/main" xmlns:p="http://schemas.openxmlformats.org/presentationml/2006/main" xmlns:r="http://schemas.openxmlformats.org/officeDocument/2006/relationships">
-  <p:cSld>
-    <p:spTree>
-      <p:nvGrpSpPr>
-        <p:cNvPr id="1" name=""/>
-        <p:cNvGrpSpPr/>
-        <p:nvPr/>
-      </p:nvGrpSpPr>
-      <p:grpSpPr/>
-      <p:pic>
-        <p:nvPicPr>
-          <p:cNvPr id="2" name="Picture 1" descr="11. Chữ chạy dần, quyền kiểm vẫn nguyên."/>
-          <p:cNvPicPr>
-            <a:picLocks noChangeAspect="1"/>
-          </p:cNvPicPr>
-          <p:nvPr/>
-        </p:nvPicPr>
-        <p:blipFill>
-          <a:blip r:embed="rId2"/>
-          <a:stretch>
-            <a:fillRect/>
-          </a:stretch>
-        </p:blipFill>
-        <p:spPr>
-          <a:xfrm>
-            <a:off x="0" y="0"/>
-            <a:ext cx="12191999" cy="6858000"/>
-          </a:xfrm>
-          <a:prstGeom prst="rect">
-            <a:avLst/>
-          </a:prstGeom>
-        </p:spPr>
-      </p:pic>
-    </p:spTree>
-  </p:cSld>
-  <p:clrMapOvr>
-    <a:masterClrMapping/>
-  </p:clrMapOvr>
-  <p:transition spd="med">
-    <p:fade/>
-  </p:transition>
-</p:sld>
-</file>
-
-<file path=ppt/slides/slide12.xml><?xml version="1.0" encoding="utf-8"?>
-<p:sld xmlns:a="http://schemas.openxmlformats.org/drawingml/2006/main" xmlns:p="http://schemas.openxmlformats.org/presentationml/2006/main" xmlns:r="http://schemas.openxmlformats.org/officeDocument/2006/relationships">
-  <p:cSld>
-    <p:spTree>
-      <p:nvGrpSpPr>
-        <p:cNvPr id="1" name=""/>
-        <p:cNvGrpSpPr/>
-        <p:nvPr/>
-      </p:nvGrpSpPr>
-      <p:grpSpPr/>
-      <p:pic>
-        <p:nvPicPr>
-          <p:cNvPr id="2" name="Picture 1" descr="12. Nói → sửa bản chép → tự gửi."/>
-          <p:cNvPicPr>
-            <a:picLocks noChangeAspect="1"/>
-          </p:cNvPicPr>
-          <p:nvPr/>
-        </p:nvPicPr>
-        <p:blipFill>
-          <a:blip r:embed="rId2"/>
-          <a:stretch>
-            <a:fillRect/>
-          </a:stretch>
-        </p:blipFill>
-        <p:spPr>
-          <a:xfrm>
-            <a:off x="0" y="0"/>
-            <a:ext cx="12191999" cy="6858000"/>
-          </a:xfrm>
-          <a:prstGeom prst="rect">
-            <a:avLst/>
-          </a:prstGeom>
-        </p:spPr>
-      </p:pic>
-    </p:spTree>
-  </p:cSld>
-  <p:clrMapOvr>
-    <a:masterClrMapping/>
-  </p:clrMapOvr>
-  <p:transition spd="med">
-    <p:fade/>
-  </p:transition>
-</p:sld>
-</file>
-
-<file path=ppt/slides/slide13.xml><?xml version="1.0" encoding="utf-8"?>
-<p:sld xmlns:a="http://schemas.openxmlformats.org/drawingml/2006/main" xmlns:p="http://schemas.openxmlformats.org/presentationml/2006/main" xmlns:r="http://schemas.openxmlformats.org/officeDocument/2006/relationships">
-  <p:cSld>
-    <p:spTree>
-      <p:nvGrpSpPr>
-        <p:cNvPr id="1" name=""/>
-        <p:cNvGrpSpPr/>
-        <p:nvPr/>
-      </p:nvGrpSpPr>
-      <p:grpSpPr/>
-      <p:pic>
-        <p:nvPicPr>
-          <p:cNvPr id="2" name="Picture 1" descr="13. Chặn trước. Đo đúng sau."/>
-          <p:cNvPicPr>
-            <a:picLocks noChangeAspect="1"/>
-          </p:cNvPicPr>
-          <p:nvPr/>
-        </p:nvPicPr>
-        <p:blipFill>
-          <a:blip r:embed="rId2"/>
-          <a:stretch>
-            <a:fillRect/>
-          </a:stretch>
-        </p:blipFill>
-        <p:spPr>
-          <a:xfrm>
-            <a:off x="0" y="0"/>
-            <a:ext cx="12191999" cy="6858000"/>
-          </a:xfrm>
-          <a:prstGeom prst="rect">
-            <a:avLst/>
-          </a:prstGeom>
-        </p:spPr>
-      </p:pic>
-    </p:spTree>
-  </p:cSld>
-  <p:clrMapOvr>
-    <a:masterClrMapping/>
-  </p:clrMapOvr>
-  <p:transition spd="med">
-    <p:fade/>
-  </p:transition>
-</p:sld>
-</file>
-
-<file path=ppt/slides/slide14.xml><?xml version="1.0" encoding="utf-8"?>
-<p:sld xmlns:a="http://schemas.openxmlformats.org/drawingml/2006/main" xmlns:p="http://schemas.openxmlformats.org/presentationml/2006/main" xmlns:r="http://schemas.openxmlformats.org/officeDocument/2006/relationships">
-  <p:cSld>
-    <p:spTree>
-      <p:nvGrpSpPr>
-        <p:cNvPr id="1" name=""/>
-        <p:cNvGrpSpPr/>
-        <p:nvPr/>
-      </p:nvGrpSpPr>
-      <p:grpSpPr/>
-      <p:pic>
-        <p:nvPicPr>
-          <p:cNvPr id="2" name="Picture 1" descr="14. Đóng gói app. Giữ dữ liệu bền."/>
-          <p:cNvPicPr>
-            <a:picLocks noChangeAspect="1"/>
-          </p:cNvPicPr>
-          <p:nvPr/>
-        </p:nvPicPr>
-        <p:blipFill>
-          <a:blip r:embed="rId2"/>
-          <a:stretch>
-            <a:fillRect/>
-          </a:stretch>
-        </p:blipFill>
-        <p:spPr>
-          <a:xfrm>
-            <a:off x="0" y="0"/>
-            <a:ext cx="12191999" cy="6858000"/>
-          </a:xfrm>
-          <a:prstGeom prst="rect">
-            <a:avLst/>
-          </a:prstGeom>
-        </p:spPr>
-      </p:pic>
-    </p:spTree>
-  </p:cSld>
-  <p:clrMapOvr>
-    <a:masterClrMapping/>
-  </p:clrMapOvr>
-  <p:transition spd="med">
-    <p:fade/>
-  </p:transition>
-</p:sld>
-</file>
-
-<file path=ppt/slides/slide15.xml><?xml version="1.0" encoding="utf-8"?>
-<p:sld xmlns:a="http://schemas.openxmlformats.org/drawingml/2006/main" xmlns:p="http://schemas.openxmlformats.org/presentationml/2006/main" xmlns:r="http://schemas.openxmlformats.org/officeDocument/2006/relationships">
-  <p:cSld>
-    <p:spTree>
-      <p:nvGrpSpPr>
-        <p:cNvPr id="1" name=""/>
-        <p:cNvGrpSpPr/>
-        <p:nvPr/>
-      </p:nvGrpSpPr>
-      <p:grpSpPr/>
-      <p:pic>
-        <p:nvPicPr>
-          <p:cNvPr id="2" name="Picture 1" descr="15. Đúng đường chạy. Đúng mức bằng chứng."/>
+          <p:cNvPr id="2" name="Picture 1" descr="10. Đúng đường chạy. Đúng mức bằng chứng."/>
           <p:cNvPicPr>
             <a:picLocks noChangeAspect="1"/>
           </p:cNvPicPr>
@@ -5534,7 +4949,7 @@
       <p:grpSpPr/>
       <p:pic>
         <p:nvPicPr>
-          <p:cNvPr id="2" name="Picture 1" descr="02. Một request. Ba ranh giới."/>
+          <p:cNvPr id="2" name="Picture 1" descr="02. Một kiến trúc, các lớp kiểm soát rõ ràng."/>
           <p:cNvPicPr>
             <a:picLocks noChangeAspect="1"/>
           </p:cNvPicPr>
@@ -5624,7 +5039,7 @@
       <p:grpSpPr/>
       <p:pic>
         <p:nvPicPr>
-          <p:cNvPr id="2" name="Picture 1" descr="04. Không tin request chỉ vì nó đến từ UI."/>
+          <p:cNvPr id="2" name="Picture 1" descr="04. Đúng danh tính. Đúng workspace. Đúng dữ liệu."/>
           <p:cNvPicPr>
             <a:picLocks noChangeAspect="1"/>
           </p:cNvPicPr>
@@ -5669,7 +5084,7 @@
       <p:grpSpPr/>
       <p:pic>
         <p:nvPicPr>
-          <p:cNvPr id="2" name="Picture 1" descr="05. Đăng nhập ≠ có quyền ghi."/>
+          <p:cNvPr id="2" name="Picture 1" descr="05. Từ PDF đến câu trả lời có nguồn."/>
           <p:cNvPicPr>
             <a:picLocks noChangeAspect="1"/>
           </p:cNvPicPr>
@@ -5714,7 +5129,7 @@
       <p:grpSpPr/>
       <p:pic>
         <p:nvPicPr>
-          <p:cNvPr id="2" name="Picture 1" descr="06. Dữ liệu quan hệ. Vector. Cùng PostgreSQL."/>
+          <p:cNvPr id="2" name="Picture 1" descr="06. AI có cấu trúc → luyện tập dùng được."/>
           <p:cNvPicPr>
             <a:picLocks noChangeAspect="1"/>
           </p:cNvPicPr>
@@ -5759,7 +5174,7 @@
       <p:grpSpPr/>
       <p:pic>
         <p:nvPicPr>
-          <p:cNvPr id="2" name="Picture 1" descr="07. PDF trở thành bằng chứng có thể tìm."/>
+          <p:cNvPr id="2" name="Picture 1" descr="07. Đầu vào giọng nói. Đầu ra có kiểm soát."/>
           <p:cNvPicPr>
             <a:picLocks noChangeAspect="1"/>
           </p:cNvPicPr>
@@ -5804,7 +5219,7 @@
       <p:grpSpPr/>
       <p:pic>
         <p:nvPicPr>
-          <p:cNvPr id="2" name="Picture 1" descr="08. Tìm đúng nguồn. Rồi mới trả lời."/>
+          <p:cNvPr id="2" name="Picture 1" descr="08. Chặn trước. Đo đúng sau."/>
           <p:cNvPicPr>
             <a:picLocks noChangeAspect="1"/>
           </p:cNvPicPr>
@@ -5849,7 +5264,7 @@
       <p:grpSpPr/>
       <p:pic>
         <p:nvPicPr>
-          <p:cNvPr id="2" name="Picture 1" descr="09. Đầu ra có cấu trúc, dùng được trong app."/>
+          <p:cNvPr id="2" name="Picture 1" descr="09. Đóng gói app. Giữ dữ liệu bền."/>
           <p:cNvPicPr>
             <a:picLocks noChangeAspect="1"/>
           </p:cNvPicPr>

</xml_diff>

<commit_message>
docs: emphasize active explanations in technology slides
</commit_message>
<xml_diff>
--- a/docs/submission/ExaMate-Technologies-VI-20261026.pptx
+++ b/docs/submission/ExaMate-Technologies-VI-20261026.pptx
@@ -1206,27 +1206,32 @@
           </a:p>
           <a:p>
             <a:r>
-              <a:t>            document/page trên server, nhưng claim grounding còn phải đối</a:t>
-            </a:r>
-          </a:p>
-          <a:p>
-            <a:r>
-              <a:t>            chiếu.” Thắng có đóng góp RAG đã được Tài xác nhận, không gán riêng</a:t>
-            </a:r>
-          </a:p>
-          <a:p>
-            <a:r>
-              <a:t>            toàn bộ cho một người. Code: rag-retrieval.service.ts,</a:t>
-            </a:r>
-          </a:p>
-          <a:p>
-            <a:r>
-              <a:t>            rag-context.ts, source-markers.ts, prompt-registry.ts. Hỏi ngoài PDF</a:t>
-            </a:r>
-          </a:p>
-          <a:p>
-            <a:r>
-              <a:t>            có thể tốn query embedding nhưng không answer generation.</a:t>
+              <a:t>            document/page trên server. Citation hợp lệ không tự chứng minh claim</a:t>
+            </a:r>
+          </a:p>
+          <a:p>
+            <a:r>
+              <a:t>            đúng; claim grounding còn phải đối chiếu.” Thắng có đóng góp RAG đã</a:t>
+            </a:r>
+          </a:p>
+          <a:p>
+            <a:r>
+              <a:t>            được Tài xác nhận, không gán riêng toàn bộ cho một người. Code:</a:t>
+            </a:r>
+          </a:p>
+          <a:p>
+            <a:r>
+              <a:t>            rag-retrieval.service.ts, rag-context.ts, source-markers.ts,</a:t>
+            </a:r>
+          </a:p>
+          <a:p>
+            <a:r>
+              <a:t>            prompt-registry.ts. Hỏi ngoài PDF có thể tốn query embedding nhưng</a:t>
+            </a:r>
+          </a:p>
+          <a:p>
+            <a:r>
+              <a:t>            không answer generation.</a:t>
             </a:r>
           </a:p>
           <a:p>

</xml_diff>